<commit_message>
Label data passed between stages in overview figure
Co-Authored-By: Claude Sonnet 5.5 <noreply@anthropic.com>
Claude-Session: https://claude.ai/code/session_01T6gEewJ8YaCdmnsfS34RJd
</commit_message>
<xml_diff>
--- a/results/seminar/figs/overview.pptx
+++ b/results/seminar/figs/overview.pptx
@@ -1350,7 +1350,46 @@
       </p:sp>
       <p:sp>
         <p:nvSpPr>
-          <p:cNvPr id="15" name="Shape 13"/>
+          <p:cNvPr id="15" name="Text 13"/>
+          <p:cNvSpPr/>
+          <p:nvPr/>
+        </p:nvSpPr>
+        <p:spPr>
+          <a:xfrm>
+            <a:off x="6355080" y="2185416"/>
+            <a:ext cx="5029200" cy="219456"/>
+          </a:xfrm>
+          <a:prstGeom prst="rect">
+            <a:avLst/>
+          </a:prstGeom>
+          <a:noFill/>
+          <a:ln/>
+        </p:spPr>
+        <p:txBody>
+          <a:bodyPr wrap="square" lIns="0" tIns="0" rIns="0" bIns="0" rtlCol="0" anchor="ctr"/>
+          <a:lstStyle/>
+          <a:p>
+            <a:pPr indent="0" marL="0">
+              <a:buNone/>
+            </a:pPr>
+            <a:r>
+              <a:rPr lang="en-US" sz="1100" b="1" i="1" dirty="0">
+                <a:solidFill>
+                  <a:srgbClr val="E0457B"/>
+                </a:solidFill>
+                <a:latin typeface="Calibri" pitchFamily="34" charset="0"/>
+                <a:ea typeface="Calibri" pitchFamily="34" charset="-122"/>
+                <a:cs typeface="Calibri" pitchFamily="34" charset="-120"/>
+              </a:rPr>
+              <a:t>16,384 training vectors (16-D)</a:t>
+            </a:r>
+            <a:endParaRPr lang="en-US" sz="1100" dirty="0"/>
+          </a:p>
+        </p:txBody>
+      </p:sp>
+      <p:sp>
+        <p:nvSpPr>
+          <p:cNvPr id="16" name="Shape 14"/>
           <p:cNvSpPr/>
           <p:nvPr/>
         </p:nvSpPr>
@@ -1375,7 +1414,7 @@
       </p:sp>
       <p:sp>
         <p:nvSpPr>
-          <p:cNvPr id="16" name="Shape 14"/>
+          <p:cNvPr id="17" name="Shape 15"/>
           <p:cNvSpPr/>
           <p:nvPr/>
         </p:nvSpPr>
@@ -1402,7 +1441,7 @@
       </p:sp>
       <p:sp>
         <p:nvSpPr>
-          <p:cNvPr id="17" name="Shape 15"/>
+          <p:cNvPr id="18" name="Shape 16"/>
           <p:cNvSpPr/>
           <p:nvPr/>
         </p:nvSpPr>
@@ -1429,7 +1468,7 @@
       </p:sp>
       <p:sp>
         <p:nvSpPr>
-          <p:cNvPr id="18" name="Text 16"/>
+          <p:cNvPr id="19" name="Text 17"/>
           <p:cNvSpPr/>
           <p:nvPr/>
         </p:nvSpPr>
@@ -1485,7 +1524,7 @@
       </p:sp>
       <p:sp>
         <p:nvSpPr>
-          <p:cNvPr id="19" name="Shape 17"/>
+          <p:cNvPr id="20" name="Shape 18"/>
           <p:cNvSpPr/>
           <p:nvPr/>
         </p:nvSpPr>
@@ -1512,7 +1551,7 @@
       </p:sp>
       <p:sp>
         <p:nvSpPr>
-          <p:cNvPr id="20" name="Text 18"/>
+          <p:cNvPr id="21" name="Text 19"/>
           <p:cNvSpPr/>
           <p:nvPr/>
         </p:nvSpPr>
@@ -1568,7 +1607,7 @@
       </p:sp>
       <p:sp>
         <p:nvSpPr>
-          <p:cNvPr id="21" name="Shape 19"/>
+          <p:cNvPr id="22" name="Shape 20"/>
           <p:cNvSpPr/>
           <p:nvPr/>
         </p:nvSpPr>
@@ -1593,7 +1632,7 @@
       </p:sp>
       <p:sp>
         <p:nvSpPr>
-          <p:cNvPr id="22" name="Shape 20"/>
+          <p:cNvPr id="23" name="Shape 21"/>
           <p:cNvSpPr/>
           <p:nvPr/>
         </p:nvSpPr>
@@ -1620,7 +1659,7 @@
       </p:sp>
       <p:sp>
         <p:nvSpPr>
-          <p:cNvPr id="23" name="Text 21"/>
+          <p:cNvPr id="24" name="Text 22"/>
           <p:cNvSpPr/>
           <p:nvPr/>
         </p:nvSpPr>
@@ -1676,7 +1715,7 @@
       </p:sp>
       <p:sp>
         <p:nvSpPr>
-          <p:cNvPr id="24" name="Shape 22"/>
+          <p:cNvPr id="25" name="Shape 23"/>
           <p:cNvSpPr/>
           <p:nvPr/>
         </p:nvSpPr>
@@ -1701,7 +1740,7 @@
       </p:sp>
       <p:sp>
         <p:nvSpPr>
-          <p:cNvPr id="25" name="Shape 23"/>
+          <p:cNvPr id="26" name="Shape 24"/>
           <p:cNvSpPr/>
           <p:nvPr/>
         </p:nvSpPr>
@@ -1728,7 +1767,7 @@
       </p:sp>
       <p:sp>
         <p:nvSpPr>
-          <p:cNvPr id="26" name="Text 24"/>
+          <p:cNvPr id="27" name="Text 25"/>
           <p:cNvSpPr/>
           <p:nvPr/>
         </p:nvSpPr>
@@ -1784,7 +1823,7 @@
       </p:sp>
       <p:sp>
         <p:nvSpPr>
-          <p:cNvPr id="27" name="Shape 25"/>
+          <p:cNvPr id="28" name="Shape 26"/>
           <p:cNvSpPr/>
           <p:nvPr/>
         </p:nvSpPr>
@@ -1809,7 +1848,7 @@
       </p:sp>
       <p:sp>
         <p:nvSpPr>
-          <p:cNvPr id="28" name="Shape 26"/>
+          <p:cNvPr id="29" name="Shape 27"/>
           <p:cNvSpPr/>
           <p:nvPr/>
         </p:nvSpPr>
@@ -1836,7 +1875,7 @@
       </p:sp>
       <p:sp>
         <p:nvSpPr>
-          <p:cNvPr id="29" name="Text 27"/>
+          <p:cNvPr id="30" name="Text 28"/>
           <p:cNvSpPr/>
           <p:nvPr/>
         </p:nvSpPr>
@@ -1892,7 +1931,46 @@
       </p:sp>
       <p:sp>
         <p:nvSpPr>
-          <p:cNvPr id="30" name="Shape 28"/>
+          <p:cNvPr id="31" name="Text 29"/>
+          <p:cNvSpPr/>
+          <p:nvPr/>
+        </p:nvSpPr>
+        <p:spPr>
+          <a:xfrm>
+            <a:off x="6355080" y="3575304"/>
+            <a:ext cx="5029200" cy="219456"/>
+          </a:xfrm>
+          <a:prstGeom prst="rect">
+            <a:avLst/>
+          </a:prstGeom>
+          <a:noFill/>
+          <a:ln/>
+        </p:spPr>
+        <p:txBody>
+          <a:bodyPr wrap="square" lIns="0" tIns="0" rIns="0" bIns="0" rtlCol="0" anchor="ctr"/>
+          <a:lstStyle/>
+          <a:p>
+            <a:pPr indent="0" marL="0">
+              <a:buNone/>
+            </a:pPr>
+            <a:r>
+              <a:rPr lang="en-US" sz="1100" b="1" i="1" dirty="0">
+                <a:solidFill>
+                  <a:srgbClr val="E0457B"/>
+                </a:solidFill>
+                <a:latin typeface="Calibri" pitchFamily="34" charset="0"/>
+                <a:ea typeface="Calibri" pitchFamily="34" charset="-122"/>
+                <a:cs typeface="Calibri" pitchFamily="34" charset="-120"/>
+              </a:rPr>
+              <a:t>codebook C (64 codewords) + index array L (gathered on Rank 0)</a:t>
+            </a:r>
+            <a:endParaRPr lang="en-US" sz="1100" dirty="0"/>
+          </a:p>
+        </p:txBody>
+      </p:sp>
+      <p:sp>
+        <p:nvSpPr>
+          <p:cNvPr id="32" name="Shape 30"/>
           <p:cNvSpPr/>
           <p:nvPr/>
         </p:nvSpPr>
@@ -1917,7 +1995,7 @@
       </p:sp>
       <p:sp>
         <p:nvSpPr>
-          <p:cNvPr id="31" name="Shape 29"/>
+          <p:cNvPr id="33" name="Shape 31"/>
           <p:cNvSpPr/>
           <p:nvPr/>
         </p:nvSpPr>
@@ -1944,7 +2022,7 @@
       </p:sp>
       <p:sp>
         <p:nvSpPr>
-          <p:cNvPr id="32" name="Shape 30"/>
+          <p:cNvPr id="34" name="Shape 32"/>
           <p:cNvSpPr/>
           <p:nvPr/>
         </p:nvSpPr>
@@ -1971,7 +2049,7 @@
       </p:sp>
       <p:sp>
         <p:nvSpPr>
-          <p:cNvPr id="33" name="Text 31"/>
+          <p:cNvPr id="35" name="Text 33"/>
           <p:cNvSpPr/>
           <p:nvPr/>
         </p:nvSpPr>
@@ -2027,7 +2105,7 @@
       </p:sp>
       <p:sp>
         <p:nvSpPr>
-          <p:cNvPr id="34" name="Shape 32"/>
+          <p:cNvPr id="36" name="Shape 34"/>
           <p:cNvSpPr/>
           <p:nvPr/>
         </p:nvSpPr>
@@ -2054,7 +2132,7 @@
       </p:sp>
       <p:sp>
         <p:nvSpPr>
-          <p:cNvPr id="35" name="Text 33"/>
+          <p:cNvPr id="37" name="Text 35"/>
           <p:cNvSpPr/>
           <p:nvPr/>
         </p:nvSpPr>
@@ -2110,7 +2188,7 @@
       </p:sp>
       <p:sp>
         <p:nvSpPr>
-          <p:cNvPr id="36" name="Shape 34"/>
+          <p:cNvPr id="38" name="Shape 36"/>
           <p:cNvSpPr/>
           <p:nvPr/>
         </p:nvSpPr>
@@ -2135,7 +2213,7 @@
       </p:sp>
       <p:sp>
         <p:nvSpPr>
-          <p:cNvPr id="37" name="Shape 35"/>
+          <p:cNvPr id="39" name="Shape 37"/>
           <p:cNvSpPr/>
           <p:nvPr/>
         </p:nvSpPr>
@@ -2162,7 +2240,7 @@
       </p:sp>
       <p:sp>
         <p:nvSpPr>
-          <p:cNvPr id="38" name="Text 36"/>
+          <p:cNvPr id="40" name="Text 38"/>
           <p:cNvSpPr/>
           <p:nvPr/>
         </p:nvSpPr>
@@ -2218,7 +2296,7 @@
       </p:sp>
       <p:sp>
         <p:nvSpPr>
-          <p:cNvPr id="39" name="Shape 37"/>
+          <p:cNvPr id="41" name="Shape 39"/>
           <p:cNvSpPr/>
           <p:nvPr/>
         </p:nvSpPr>
@@ -2243,7 +2321,7 @@
       </p:sp>
       <p:sp>
         <p:nvSpPr>
-          <p:cNvPr id="40" name="Shape 38"/>
+          <p:cNvPr id="42" name="Shape 40"/>
           <p:cNvSpPr/>
           <p:nvPr/>
         </p:nvSpPr>
@@ -2270,7 +2348,7 @@
       </p:sp>
       <p:sp>
         <p:nvSpPr>
-          <p:cNvPr id="41" name="Text 39"/>
+          <p:cNvPr id="43" name="Text 41"/>
           <p:cNvSpPr/>
           <p:nvPr/>
         </p:nvSpPr>
@@ -2326,7 +2404,46 @@
       </p:sp>
       <p:sp>
         <p:nvSpPr>
-          <p:cNvPr id="42" name="Shape 40"/>
+          <p:cNvPr id="44" name="Text 42"/>
+          <p:cNvSpPr/>
+          <p:nvPr/>
+        </p:nvSpPr>
+        <p:spPr>
+          <a:xfrm>
+            <a:off x="6355080" y="4965192"/>
+            <a:ext cx="5029200" cy="219456"/>
+          </a:xfrm>
+          <a:prstGeom prst="rect">
+            <a:avLst/>
+          </a:prstGeom>
+          <a:noFill/>
+          <a:ln/>
+        </p:spPr>
+        <p:txBody>
+          <a:bodyPr wrap="square" lIns="0" tIns="0" rIns="0" bIns="0" rtlCol="0" anchor="ctr"/>
+          <a:lstStyle/>
+          <a:p>
+            <a:pPr indent="0" marL="0">
+              <a:buNone/>
+            </a:pPr>
+            <a:r>
+              <a:rPr lang="en-US" sz="1100" b="1" i="1" dirty="0">
+                <a:solidFill>
+                  <a:srgbClr val="E0457B"/>
+                </a:solidFill>
+                <a:latin typeface="Calibri" pitchFamily="34" charset="0"/>
+                <a:ea typeface="Calibri" pitchFamily="34" charset="-122"/>
+                <a:cs typeface="Calibri" pitchFamily="34" charset="-120"/>
+              </a:rPr>
+              <a:t>compressed data: codebook + Huffman table + bitstream</a:t>
+            </a:r>
+            <a:endParaRPr lang="en-US" sz="1100" dirty="0"/>
+          </a:p>
+        </p:txBody>
+      </p:sp>
+      <p:sp>
+        <p:nvSpPr>
+          <p:cNvPr id="45" name="Shape 43"/>
           <p:cNvSpPr/>
           <p:nvPr/>
         </p:nvSpPr>
@@ -2351,7 +2468,7 @@
       </p:sp>
       <p:sp>
         <p:nvSpPr>
-          <p:cNvPr id="43" name="Shape 41"/>
+          <p:cNvPr id="46" name="Shape 44"/>
           <p:cNvSpPr/>
           <p:nvPr/>
         </p:nvSpPr>
@@ -2378,7 +2495,7 @@
       </p:sp>
       <p:sp>
         <p:nvSpPr>
-          <p:cNvPr id="44" name="Shape 42"/>
+          <p:cNvPr id="47" name="Shape 45"/>
           <p:cNvSpPr/>
           <p:nvPr/>
         </p:nvSpPr>
@@ -2405,7 +2522,7 @@
       </p:sp>
       <p:sp>
         <p:nvSpPr>
-          <p:cNvPr id="45" name="Text 43"/>
+          <p:cNvPr id="48" name="Text 46"/>
           <p:cNvSpPr/>
           <p:nvPr/>
         </p:nvSpPr>
@@ -2461,7 +2578,7 @@
       </p:sp>
       <p:sp>
         <p:nvSpPr>
-          <p:cNvPr id="46" name="Shape 44"/>
+          <p:cNvPr id="49" name="Shape 47"/>
           <p:cNvSpPr/>
           <p:nvPr/>
         </p:nvSpPr>
@@ -2488,7 +2605,7 @@
       </p:sp>
       <p:sp>
         <p:nvSpPr>
-          <p:cNvPr id="47" name="Text 45"/>
+          <p:cNvPr id="50" name="Text 48"/>
           <p:cNvSpPr/>
           <p:nvPr/>
         </p:nvSpPr>
@@ -2544,7 +2661,7 @@
       </p:sp>
       <p:sp>
         <p:nvSpPr>
-          <p:cNvPr id="48" name="Shape 46"/>
+          <p:cNvPr id="51" name="Shape 49"/>
           <p:cNvSpPr/>
           <p:nvPr/>
         </p:nvSpPr>
@@ -2569,7 +2686,7 @@
       </p:sp>
       <p:sp>
         <p:nvSpPr>
-          <p:cNvPr id="49" name="Shape 47"/>
+          <p:cNvPr id="52" name="Shape 50"/>
           <p:cNvSpPr/>
           <p:nvPr/>
         </p:nvSpPr>
@@ -2596,7 +2713,7 @@
       </p:sp>
       <p:sp>
         <p:nvSpPr>
-          <p:cNvPr id="50" name="Text 48"/>
+          <p:cNvPr id="53" name="Text 51"/>
           <p:cNvSpPr/>
           <p:nvPr/>
         </p:nvSpPr>
@@ -2652,7 +2769,7 @@
       </p:sp>
       <p:sp>
         <p:nvSpPr>
-          <p:cNvPr id="51" name="Shape 49"/>
+          <p:cNvPr id="54" name="Shape 52"/>
           <p:cNvSpPr/>
           <p:nvPr/>
         </p:nvSpPr>
@@ -2677,7 +2794,7 @@
       </p:sp>
       <p:sp>
         <p:nvSpPr>
-          <p:cNvPr id="52" name="Shape 50"/>
+          <p:cNvPr id="55" name="Shape 53"/>
           <p:cNvSpPr/>
           <p:nvPr/>
         </p:nvSpPr>
@@ -2704,7 +2821,7 @@
       </p:sp>
       <p:sp>
         <p:nvSpPr>
-          <p:cNvPr id="53" name="Text 51"/>
+          <p:cNvPr id="56" name="Text 54"/>
           <p:cNvSpPr/>
           <p:nvPr/>
         </p:nvSpPr>
@@ -2760,7 +2877,7 @@
       </p:sp>
       <p:sp>
         <p:nvSpPr>
-          <p:cNvPr id="54" name="Shape 52"/>
+          <p:cNvPr id="57" name="Shape 55"/>
           <p:cNvSpPr/>
           <p:nvPr/>
         </p:nvSpPr>
@@ -2785,7 +2902,7 @@
       </p:sp>
       <p:sp>
         <p:nvSpPr>
-          <p:cNvPr id="55" name="Shape 53"/>
+          <p:cNvPr id="58" name="Shape 56"/>
           <p:cNvSpPr/>
           <p:nvPr/>
         </p:nvSpPr>
@@ -2812,7 +2929,7 @@
       </p:sp>
       <p:sp>
         <p:nvSpPr>
-          <p:cNvPr id="56" name="Text 54"/>
+          <p:cNvPr id="59" name="Text 57"/>
           <p:cNvSpPr/>
           <p:nvPr/>
         </p:nvSpPr>
@@ -2868,7 +2985,32 @@
       </p:sp>
       <p:sp>
         <p:nvSpPr>
-          <p:cNvPr id="57" name="Text 55"/>
+          <p:cNvPr id="60" name="Shape 58"/>
+          <p:cNvSpPr/>
+          <p:nvPr/>
+        </p:nvSpPr>
+        <p:spPr>
+          <a:xfrm>
+            <a:off x="5989320" y="6373368"/>
+            <a:ext cx="237744" cy="182880"/>
+          </a:xfrm>
+          <a:prstGeom prst="downArrow">
+            <a:avLst/>
+          </a:prstGeom>
+          <a:solidFill>
+            <a:srgbClr val="1F1A33"/>
+          </a:solidFill>
+          <a:ln w="12700">
+            <a:solidFill>
+              <a:srgbClr val="1F1A33"/>
+            </a:solidFill>
+            <a:prstDash val="solid"/>
+          </a:ln>
+        </p:spPr>
+      </p:sp>
+      <p:sp>
+        <p:nvSpPr>
+          <p:cNvPr id="61" name="Text 59"/>
           <p:cNvSpPr/>
           <p:nvPr/>
         </p:nvSpPr>

</xml_diff>

<commit_message>
Apply supervisor edits to overview figure labels
Co-Authored-By: Claude Sonnet 5.5 <noreply@anthropic.com>
Claude-Session: https://claude.ai/code/session_01T6gEewJ8YaCdmnsfS34RJd
</commit_message>
<xml_diff>
--- a/results/seminar/figs/overview.pptx
+++ b/results/seminar/figs/overview.pptx
@@ -1815,7 +1815,24 @@
                 <a:ea typeface="Calibri" pitchFamily="34" charset="-122"/>
                 <a:cs typeface="Calibri" pitchFamily="34" charset="-120"/>
               </a:rPr>
-              <a:t>Allreduce of sums and counts</a:t>
+              <a:t>Allreduce:</a:t>
+            </a:r>
+            <a:endParaRPr lang="en-US" sz="1400" dirty="0"/>
+          </a:p>
+          <a:p>
+            <a:pPr algn="ctr" indent="0" marL="0">
+              <a:buNone/>
+            </a:pPr>
+            <a:r>
+              <a:rPr lang="en-US" sz="1100" dirty="0">
+                <a:solidFill>
+                  <a:srgbClr val="1F1A33"/>
+                </a:solidFill>
+                <a:latin typeface="Calibri" pitchFamily="34" charset="0"/>
+                <a:ea typeface="Calibri" pitchFamily="34" charset="-122"/>
+                <a:cs typeface="Calibri" pitchFamily="34" charset="-120"/>
+              </a:rPr>
+              <a:t>sums, counts, distortion</a:t>
             </a:r>
             <a:endParaRPr lang="en-US" sz="1400" dirty="0"/>
           </a:p>
@@ -1906,7 +1923,7 @@
                 <a:ea typeface="Calibri" pitchFamily="34" charset="-122"/>
                 <a:cs typeface="Calibri" pitchFamily="34" charset="-120"/>
               </a:rPr>
-              <a:t>4. Update, repeat</a:t>
+              <a:t>4. Refine and split</a:t>
             </a:r>
             <a:endParaRPr lang="en-US" sz="1400" dirty="0"/>
           </a:p>
@@ -1923,7 +1940,7 @@
                 <a:ea typeface="Calibri" pitchFamily="34" charset="-122"/>
                 <a:cs typeface="Calibri" pitchFamily="34" charset="-120"/>
               </a:rPr>
-              <a:t>until converged (K = 64)</a:t>
+              <a:t>per level, until K = 64</a:t>
             </a:r>
             <a:endParaRPr lang="en-US" sz="1400" dirty="0"/>
           </a:p>
@@ -2097,7 +2114,7 @@
                 <a:ea typeface="Calibri" pitchFamily="34" charset="-122"/>
                 <a:cs typeface="Calibri" pitchFamily="34" charset="-120"/>
               </a:rPr>
-              <a:t>Entropy Coding (Rank 0)</a:t>
+              <a:t>Lossless Index Coding (Rank 0)</a:t>
             </a:r>
             <a:endParaRPr lang="en-US" sz="1800" dirty="0"/>
           </a:p>
@@ -2396,7 +2413,24 @@
                 <a:ea typeface="Calibri" pitchFamily="34" charset="-122"/>
                 <a:cs typeface="Calibri" pitchFamily="34" charset="-120"/>
               </a:rPr>
-              <a:t>codebook + table + bitstream</a:t>
+              <a:t>codebook + Huffman table</a:t>
+            </a:r>
+            <a:endParaRPr lang="en-US" sz="1400" dirty="0"/>
+          </a:p>
+          <a:p>
+            <a:pPr algn="ctr" indent="0" marL="0">
+              <a:buNone/>
+            </a:pPr>
+            <a:r>
+              <a:rPr lang="en-US" sz="1100" dirty="0">
+                <a:solidFill>
+                  <a:srgbClr val="1F1A33"/>
+                </a:solidFill>
+                <a:latin typeface="Calibri" pitchFamily="34" charset="0"/>
+                <a:ea typeface="Calibri" pitchFamily="34" charset="-122"/>
+                <a:cs typeface="Calibri" pitchFamily="34" charset="-120"/>
+              </a:rPr>
+              <a:t>+ coded indices</a:t>
             </a:r>
             <a:endParaRPr lang="en-US" sz="1400" dirty="0"/>
           </a:p>
@@ -2435,7 +2469,7 @@
                 <a:ea typeface="Calibri" pitchFamily="34" charset="-122"/>
                 <a:cs typeface="Calibri" pitchFamily="34" charset="-120"/>
               </a:rPr>
-              <a:t>compressed data: codebook + Huffman table + bitstream</a:t>
+              <a:t>compressed data: codebook + Huffman table + coded indices</a:t>
             </a:r>
             <a:endParaRPr lang="en-US" sz="1100" dirty="0"/>
           </a:p>
@@ -2977,7 +3011,24 @@
                 <a:ea typeface="Calibri" pitchFamily="34" charset="-122"/>
                 <a:cs typeface="Calibri" pitchFamily="34" charset="-120"/>
               </a:rPr>
-              <a:t>CR, PSNR, SSIM (parallel)</a:t>
+              <a:t>CR, BPP, MSE, PSNR;</a:t>
+            </a:r>
+            <a:endParaRPr lang="en-US" sz="1400" dirty="0"/>
+          </a:p>
+          <a:p>
+            <a:pPr algn="ctr" indent="0" marL="0">
+              <a:buNone/>
+            </a:pPr>
+            <a:r>
+              <a:rPr lang="en-US" sz="1100" dirty="0">
+                <a:solidFill>
+                  <a:srgbClr val="1F1A33"/>
+                </a:solidFill>
+                <a:latin typeface="Calibri" pitchFamily="34" charset="0"/>
+                <a:ea typeface="Calibri" pitchFamily="34" charset="-122"/>
+                <a:cs typeface="Calibri" pitchFamily="34" charset="-120"/>
+              </a:rPr>
+              <a:t>parallel SSIM</a:t>
             </a:r>
             <a:endParaRPr lang="en-US" sz="1400" dirty="0"/>
           </a:p>
@@ -3041,7 +3092,7 @@
                 <a:ea typeface="Calibri" pitchFamily="34" charset="-122"/>
                 <a:cs typeface="Calibri" pitchFamily="34" charset="-120"/>
               </a:rPr>
-              <a:t>Parallel: LBG training and SSIM   |   Rank 0: coding, decoding and reconstruction</a:t>
+              <a:t>Parallel: LBG training and SSIM   |   Rank 0: coding, decoding, reconstruction, and remaining metrics</a:t>
             </a:r>
             <a:endParaRPr lang="en-US" sz="1200" dirty="0"/>
           </a:p>

</xml_diff>

<commit_message>
Overview figure: MPI_Scatterv label and precise footer
Co-Authored-By: Claude Sonnet 5.5 <noreply@anthropic.com>
Claude-Session: https://claude.ai/code/session_01T6gEewJ8YaCdmnsfS34RJd
</commit_message>
<xml_diff>
--- a/results/seminar/figs/overview.pptx
+++ b/results/seminar/figs/overview.pptx
@@ -1599,7 +1599,24 @@
                 <a:ea typeface="Calibri" pitchFamily="34" charset="-122"/>
                 <a:cs typeface="Calibri" pitchFamily="34" charset="-120"/>
               </a:rPr>
-              <a:t>Scatterv: Equal / Adaptive</a:t>
+              <a:t>MPI_Scatterv:</a:t>
+            </a:r>
+            <a:endParaRPr lang="en-US" sz="1400" dirty="0"/>
+          </a:p>
+          <a:p>
+            <a:pPr algn="ctr" indent="0" marL="0">
+              <a:buNone/>
+            </a:pPr>
+            <a:r>
+              <a:rPr lang="en-US" sz="1100" dirty="0">
+                <a:solidFill>
+                  <a:srgbClr val="1F1A33"/>
+                </a:solidFill>
+                <a:latin typeface="Calibri" pitchFamily="34" charset="0"/>
+                <a:ea typeface="Calibri" pitchFamily="34" charset="-122"/>
+                <a:cs typeface="Calibri" pitchFamily="34" charset="-120"/>
+              </a:rPr>
+              <a:t>Equal / Adaptive</a:t>
             </a:r>
             <a:endParaRPr lang="en-US" sz="1400" dirty="0"/>
           </a:p>
@@ -3092,7 +3109,7 @@
                 <a:ea typeface="Calibri" pitchFamily="34" charset="-122"/>
                 <a:cs typeface="Calibri" pitchFamily="34" charset="-120"/>
               </a:rPr>
-              <a:t>Parallel: LBG training and SSIM   |   Rank 0: coding, decoding, reconstruction, and remaining metrics</a:t>
+              <a:t>Parallel: LBG training and SSIM   |   Rank 0: index coding, decoding, reconstruction, and remaining metrics</a:t>
             </a:r>
             <a:endParaRPr lang="en-US" sz="1200" dirty="0"/>
           </a:p>

</xml_diff>

<commit_message>
Overview figure: remove title, enlarge text, rewrap labels
Co-Authored-By: Claude Sonnet 5.5 <noreply@anthropic.com>
Claude-Session: https://claude.ai/code/session_01T6gEewJ8YaCdmnsfS34RJd
</commit_message>
<xml_diff>
--- a/results/seminar/figs/overview.pptx
+++ b/results/seminar/figs/overview.pptx
@@ -877,82 +877,18 @@
       </p:grpSpPr>
       <p:sp>
         <p:nvSpPr>
-          <p:cNvPr id="2" name="Text 0"/>
-          <p:cNvSpPr/>
-          <p:nvPr/>
-        </p:nvSpPr>
-        <p:spPr>
-          <a:xfrm>
-            <a:off x="457200" y="182880"/>
-            <a:ext cx="11247120" cy="640080"/>
-          </a:xfrm>
-          <a:prstGeom prst="rect">
-            <a:avLst/>
-          </a:prstGeom>
-          <a:noFill/>
-          <a:ln/>
-        </p:spPr>
-        <p:txBody>
-          <a:bodyPr wrap="square" lIns="0" tIns="0" rIns="0" bIns="0" rtlCol="0" anchor="ctr"/>
-          <a:lstStyle/>
-          <a:p>
-            <a:pPr indent="0" marL="0">
-              <a:buNone/>
-            </a:pPr>
-            <a:r>
-              <a:rPr lang="en-US" sz="3200" b="1" dirty="0">
-                <a:solidFill>
-                  <a:srgbClr val="2E2055"/>
-                </a:solidFill>
-                <a:latin typeface="Cambria" pitchFamily="34" charset="0"/>
-                <a:ea typeface="Cambria" pitchFamily="34" charset="-122"/>
-                <a:cs typeface="Cambria" pitchFamily="34" charset="-120"/>
-              </a:rPr>
-              <a:t>Proposed Method</a:t>
-            </a:r>
-            <a:endParaRPr lang="en-US" sz="3200" dirty="0"/>
-          </a:p>
-        </p:txBody>
-      </p:sp>
-      <p:sp>
-        <p:nvSpPr>
-          <p:cNvPr id="3" name="Shape 1"/>
-          <p:cNvSpPr/>
-          <p:nvPr/>
-        </p:nvSpPr>
-        <p:spPr>
-          <a:xfrm>
-            <a:off x="457200" y="841248"/>
-            <a:ext cx="11274552" cy="36576"/>
-          </a:xfrm>
-          <a:prstGeom prst="rect">
-            <a:avLst/>
-          </a:prstGeom>
-          <a:solidFill>
-            <a:srgbClr val="E0457B"/>
-          </a:solidFill>
-          <a:ln w="12700">
-            <a:solidFill>
-              <a:srgbClr val="E0457B"/>
-            </a:solidFill>
-            <a:prstDash val="solid"/>
-          </a:ln>
-        </p:spPr>
-      </p:sp>
-      <p:sp>
-        <p:nvSpPr>
-          <p:cNvPr id="4" name="Shape 2"/>
-          <p:cNvSpPr/>
-          <p:nvPr/>
-        </p:nvSpPr>
-        <p:spPr>
-          <a:xfrm>
-            <a:off x="411480" y="1005840"/>
-            <a:ext cx="11365992" cy="1188720"/>
+          <p:cNvPr id="2" name="Shape 0"/>
+          <p:cNvSpPr/>
+          <p:nvPr/>
+        </p:nvSpPr>
+        <p:spPr>
+          <a:xfrm>
+            <a:off x="320040" y="182880"/>
+            <a:ext cx="11503152" cy="1417320"/>
           </a:xfrm>
           <a:prstGeom prst="roundRect">
             <a:avLst>
-              <a:gd name="adj" fmla="val 7692"/>
+              <a:gd name="adj" fmla="val 6452"/>
             </a:avLst>
           </a:prstGeom>
           <a:solidFill>
@@ -968,18 +904,18 @@
       </p:sp>
       <p:sp>
         <p:nvSpPr>
-          <p:cNvPr id="5" name="Shape 3"/>
-          <p:cNvSpPr/>
-          <p:nvPr/>
-        </p:nvSpPr>
-        <p:spPr>
-          <a:xfrm>
-            <a:off x="457200" y="1051560"/>
-            <a:ext cx="2148840" cy="1097280"/>
+          <p:cNvPr id="3" name="Shape 1"/>
+          <p:cNvSpPr/>
+          <p:nvPr/>
+        </p:nvSpPr>
+        <p:spPr>
+          <a:xfrm>
+            <a:off x="365760" y="228600"/>
+            <a:ext cx="2240280" cy="1325880"/>
           </a:xfrm>
           <a:prstGeom prst="roundRect">
             <a:avLst>
-              <a:gd name="adj" fmla="val 6667"/>
+              <a:gd name="adj" fmla="val 5517"/>
             </a:avLst>
           </a:prstGeom>
           <a:solidFill>
@@ -995,14 +931,14 @@
       </p:sp>
       <p:sp>
         <p:nvSpPr>
-          <p:cNvPr id="6" name="Text 4"/>
-          <p:cNvSpPr/>
-          <p:nvPr/>
-        </p:nvSpPr>
-        <p:spPr>
-          <a:xfrm>
-            <a:off x="457200" y="1051560"/>
-            <a:ext cx="2148840" cy="1097280"/>
+          <p:cNvPr id="4" name="Text 2"/>
+          <p:cNvSpPr/>
+          <p:nvPr/>
+        </p:nvSpPr>
+        <p:spPr>
+          <a:xfrm>
+            <a:off x="365760" y="228600"/>
+            <a:ext cx="2240280" cy="1325880"/>
           </a:xfrm>
           <a:prstGeom prst="rect">
             <a:avLst/>
@@ -1018,7 +954,7 @@
               <a:buNone/>
             </a:pPr>
             <a:r>
-              <a:rPr lang="en-US" sz="1800" b="1" dirty="0">
+              <a:rPr lang="en-US" sz="2200" b="1" dirty="0">
                 <a:solidFill>
                   <a:srgbClr val="FFFFFF"/>
                 </a:solidFill>
@@ -1028,14 +964,14 @@
               </a:rPr>
               <a:t>Stage 1</a:t>
             </a:r>
-            <a:endParaRPr lang="en-US" sz="1800" dirty="0"/>
-          </a:p>
-          <a:p>
-            <a:pPr algn="ctr" indent="0" marL="0">
-              <a:buNone/>
-            </a:pPr>
-            <a:r>
-              <a:rPr lang="en-US" sz="1300" dirty="0">
+            <a:endParaRPr lang="en-US" sz="2200" dirty="0"/>
+          </a:p>
+          <a:p>
+            <a:pPr algn="ctr" indent="0" marL="0">
+              <a:buNone/>
+            </a:pPr>
+            <a:r>
+              <a:rPr lang="en-US" sz="1500" dirty="0">
                 <a:solidFill>
                   <a:srgbClr val="FFFFFF"/>
                 </a:solidFill>
@@ -1043,26 +979,43 @@
                 <a:ea typeface="Calibri" pitchFamily="34" charset="-122"/>
                 <a:cs typeface="Calibri" pitchFamily="34" charset="-120"/>
               </a:rPr>
-              <a:t>Block Formation</a:t>
-            </a:r>
-            <a:endParaRPr lang="en-US" sz="1800" dirty="0"/>
+              <a:t>Block</a:t>
+            </a:r>
+            <a:endParaRPr lang="en-US" sz="2200" dirty="0"/>
+          </a:p>
+          <a:p>
+            <a:pPr algn="ctr" indent="0" marL="0">
+              <a:buNone/>
+            </a:pPr>
+            <a:r>
+              <a:rPr lang="en-US" sz="1500" dirty="0">
+                <a:solidFill>
+                  <a:srgbClr val="FFFFFF"/>
+                </a:solidFill>
+                <a:latin typeface="Calibri" pitchFamily="34" charset="0"/>
+                <a:ea typeface="Calibri" pitchFamily="34" charset="-122"/>
+                <a:cs typeface="Calibri" pitchFamily="34" charset="-120"/>
+              </a:rPr>
+              <a:t>Formation</a:t>
+            </a:r>
+            <a:endParaRPr lang="en-US" sz="2200" dirty="0"/>
           </a:p>
         </p:txBody>
       </p:sp>
       <p:sp>
         <p:nvSpPr>
-          <p:cNvPr id="7" name="Shape 5"/>
-          <p:cNvSpPr/>
-          <p:nvPr/>
-        </p:nvSpPr>
-        <p:spPr>
-          <a:xfrm>
-            <a:off x="2788920" y="1143000"/>
-            <a:ext cx="1874520" cy="914400"/>
+          <p:cNvPr id="5" name="Shape 3"/>
+          <p:cNvSpPr/>
+          <p:nvPr/>
+        </p:nvSpPr>
+        <p:spPr>
+          <a:xfrm>
+            <a:off x="2788920" y="320040"/>
+            <a:ext cx="2011680" cy="1143000"/>
           </a:xfrm>
           <a:prstGeom prst="roundRect">
             <a:avLst>
-              <a:gd name="adj" fmla="val 8000"/>
+              <a:gd name="adj" fmla="val 6400"/>
             </a:avLst>
           </a:prstGeom>
           <a:solidFill>
@@ -1078,14 +1031,14 @@
       </p:sp>
       <p:sp>
         <p:nvSpPr>
-          <p:cNvPr id="8" name="Text 6"/>
-          <p:cNvSpPr/>
-          <p:nvPr/>
-        </p:nvSpPr>
-        <p:spPr>
-          <a:xfrm>
-            <a:off x="2788920" y="1143000"/>
-            <a:ext cx="1874520" cy="914400"/>
+          <p:cNvPr id="6" name="Text 4"/>
+          <p:cNvSpPr/>
+          <p:nvPr/>
+        </p:nvSpPr>
+        <p:spPr>
+          <a:xfrm>
+            <a:off x="2788920" y="320040"/>
+            <a:ext cx="2011680" cy="1143000"/>
           </a:xfrm>
           <a:prstGeom prst="rect">
             <a:avLst/>
@@ -1094,14 +1047,14 @@
           <a:ln/>
         </p:spPr>
         <p:txBody>
-          <a:bodyPr wrap="square" lIns="762" tIns="762" rIns="762" bIns="762" rtlCol="0" anchor="ctr"/>
+          <a:bodyPr wrap="square" lIns="635" tIns="635" rIns="635" bIns="635" rtlCol="0" anchor="ctr"/>
           <a:lstStyle/>
           <a:p>
             <a:pPr algn="ctr" indent="0" marL="0">
               <a:buNone/>
             </a:pPr>
             <a:r>
-              <a:rPr lang="en-US" sz="1400" b="1" dirty="0">
+              <a:rPr lang="en-US" sz="1600" b="1" dirty="0">
                 <a:solidFill>
                   <a:srgbClr val="2F6FB5"/>
                 </a:solidFill>
@@ -1111,14 +1064,14 @@
               </a:rPr>
               <a:t>1. Input image</a:t>
             </a:r>
-            <a:endParaRPr lang="en-US" sz="1400" dirty="0"/>
-          </a:p>
-          <a:p>
-            <a:pPr algn="ctr" indent="0" marL="0">
-              <a:buNone/>
-            </a:pPr>
-            <a:r>
-              <a:rPr lang="en-US" sz="1100" dirty="0">
+            <a:endParaRPr lang="en-US" sz="1600" dirty="0"/>
+          </a:p>
+          <a:p>
+            <a:pPr algn="ctr" indent="0" marL="0">
+              <a:buNone/>
+            </a:pPr>
+            <a:r>
+              <a:rPr lang="en-US" sz="1300" dirty="0">
                 <a:solidFill>
                   <a:srgbClr val="1F1A33"/>
                 </a:solidFill>
@@ -1126,22 +1079,39 @@
                 <a:ea typeface="Calibri" pitchFamily="34" charset="-122"/>
                 <a:cs typeface="Calibri" pitchFamily="34" charset="-120"/>
               </a:rPr>
-              <a:t>512×512, gray / color</a:t>
-            </a:r>
-            <a:endParaRPr lang="en-US" sz="1400" dirty="0"/>
+              <a:t>512×512,</a:t>
+            </a:r>
+            <a:endParaRPr lang="en-US" sz="1600" dirty="0"/>
+          </a:p>
+          <a:p>
+            <a:pPr algn="ctr" indent="0" marL="0">
+              <a:buNone/>
+            </a:pPr>
+            <a:r>
+              <a:rPr lang="en-US" sz="1300" dirty="0">
+                <a:solidFill>
+                  <a:srgbClr val="1F1A33"/>
+                </a:solidFill>
+                <a:latin typeface="Calibri" pitchFamily="34" charset="0"/>
+                <a:ea typeface="Calibri" pitchFamily="34" charset="-122"/>
+                <a:cs typeface="Calibri" pitchFamily="34" charset="-120"/>
+              </a:rPr>
+              <a:t>gray / color</a:t>
+            </a:r>
+            <a:endParaRPr lang="en-US" sz="1600" dirty="0"/>
           </a:p>
         </p:txBody>
       </p:sp>
       <p:sp>
         <p:nvSpPr>
-          <p:cNvPr id="9" name="Shape 7"/>
-          <p:cNvSpPr/>
-          <p:nvPr/>
-        </p:nvSpPr>
-        <p:spPr>
-          <a:xfrm>
-            <a:off x="4709160" y="1481328"/>
-            <a:ext cx="274320" cy="237744"/>
+          <p:cNvPr id="7" name="Shape 5"/>
+          <p:cNvSpPr/>
+          <p:nvPr/>
+        </p:nvSpPr>
+        <p:spPr>
+          <a:xfrm>
+            <a:off x="4828032" y="772668"/>
+            <a:ext cx="219456" cy="237744"/>
           </a:xfrm>
           <a:prstGeom prst="rightArrow">
             <a:avLst/>
@@ -1159,18 +1129,18 @@
       </p:sp>
       <p:sp>
         <p:nvSpPr>
-          <p:cNvPr id="10" name="Shape 8"/>
-          <p:cNvSpPr/>
-          <p:nvPr/>
-        </p:nvSpPr>
-        <p:spPr>
-          <a:xfrm>
-            <a:off x="5029200" y="1143000"/>
-            <a:ext cx="1874520" cy="914400"/>
+          <p:cNvPr id="8" name="Shape 6"/>
+          <p:cNvSpPr/>
+          <p:nvPr/>
+        </p:nvSpPr>
+        <p:spPr>
+          <a:xfrm>
+            <a:off x="5074920" y="320040"/>
+            <a:ext cx="2011680" cy="1143000"/>
           </a:xfrm>
           <a:prstGeom prst="roundRect">
             <a:avLst>
-              <a:gd name="adj" fmla="val 8000"/>
+              <a:gd name="adj" fmla="val 6400"/>
             </a:avLst>
           </a:prstGeom>
           <a:solidFill>
@@ -1186,14 +1156,14 @@
       </p:sp>
       <p:sp>
         <p:nvSpPr>
-          <p:cNvPr id="11" name="Text 9"/>
-          <p:cNvSpPr/>
-          <p:nvPr/>
-        </p:nvSpPr>
-        <p:spPr>
-          <a:xfrm>
-            <a:off x="5029200" y="1143000"/>
-            <a:ext cx="1874520" cy="914400"/>
+          <p:cNvPr id="9" name="Text 7"/>
+          <p:cNvSpPr/>
+          <p:nvPr/>
+        </p:nvSpPr>
+        <p:spPr>
+          <a:xfrm>
+            <a:off x="5074920" y="320040"/>
+            <a:ext cx="2011680" cy="1143000"/>
           </a:xfrm>
           <a:prstGeom prst="rect">
             <a:avLst/>
@@ -1202,14 +1172,14 @@
           <a:ln/>
         </p:spPr>
         <p:txBody>
-          <a:bodyPr wrap="square" lIns="762" tIns="762" rIns="762" bIns="762" rtlCol="0" anchor="ctr"/>
+          <a:bodyPr wrap="square" lIns="635" tIns="635" rIns="635" bIns="635" rtlCol="0" anchor="ctr"/>
           <a:lstStyle/>
           <a:p>
             <a:pPr algn="ctr" indent="0" marL="0">
               <a:buNone/>
             </a:pPr>
             <a:r>
-              <a:rPr lang="en-US" sz="1400" b="1" dirty="0">
+              <a:rPr lang="en-US" sz="1600" b="1" dirty="0">
                 <a:solidFill>
                   <a:srgbClr val="2F6FB5"/>
                 </a:solidFill>
@@ -1219,14 +1189,14 @@
               </a:rPr>
               <a:t>2. 4×4 blocks</a:t>
             </a:r>
-            <a:endParaRPr lang="en-US" sz="1400" dirty="0"/>
-          </a:p>
-          <a:p>
-            <a:pPr algn="ctr" indent="0" marL="0">
-              <a:buNone/>
-            </a:pPr>
-            <a:r>
-              <a:rPr lang="en-US" sz="1100" dirty="0">
+            <a:endParaRPr lang="en-US" sz="1600" dirty="0"/>
+          </a:p>
+          <a:p>
+            <a:pPr algn="ctr" indent="0" marL="0">
+              <a:buNone/>
+            </a:pPr>
+            <a:r>
+              <a:rPr lang="en-US" sz="1300" dirty="0">
                 <a:solidFill>
                   <a:srgbClr val="1F1A33"/>
                 </a:solidFill>
@@ -1236,20 +1206,20 @@
               </a:rPr>
               <a:t>non-overlapping</a:t>
             </a:r>
-            <a:endParaRPr lang="en-US" sz="1400" dirty="0"/>
+            <a:endParaRPr lang="en-US" sz="1600" dirty="0"/>
           </a:p>
         </p:txBody>
       </p:sp>
       <p:sp>
         <p:nvSpPr>
-          <p:cNvPr id="12" name="Shape 10"/>
-          <p:cNvSpPr/>
-          <p:nvPr/>
-        </p:nvSpPr>
-        <p:spPr>
-          <a:xfrm>
-            <a:off x="6949440" y="1481328"/>
-            <a:ext cx="274320" cy="237744"/>
+          <p:cNvPr id="10" name="Shape 8"/>
+          <p:cNvSpPr/>
+          <p:nvPr/>
+        </p:nvSpPr>
+        <p:spPr>
+          <a:xfrm>
+            <a:off x="7114032" y="772668"/>
+            <a:ext cx="219456" cy="237744"/>
           </a:xfrm>
           <a:prstGeom prst="rightArrow">
             <a:avLst/>
@@ -1267,18 +1237,18 @@
       </p:sp>
       <p:sp>
         <p:nvSpPr>
-          <p:cNvPr id="13" name="Shape 11"/>
-          <p:cNvSpPr/>
-          <p:nvPr/>
-        </p:nvSpPr>
-        <p:spPr>
-          <a:xfrm>
-            <a:off x="7269480" y="1143000"/>
-            <a:ext cx="1874520" cy="914400"/>
+          <p:cNvPr id="11" name="Shape 9"/>
+          <p:cNvSpPr/>
+          <p:nvPr/>
+        </p:nvSpPr>
+        <p:spPr>
+          <a:xfrm>
+            <a:off x="7360920" y="320040"/>
+            <a:ext cx="2011680" cy="1143000"/>
           </a:xfrm>
           <a:prstGeom prst="roundRect">
             <a:avLst>
-              <a:gd name="adj" fmla="val 8000"/>
+              <a:gd name="adj" fmla="val 6400"/>
             </a:avLst>
           </a:prstGeom>
           <a:solidFill>
@@ -1294,14 +1264,14 @@
       </p:sp>
       <p:sp>
         <p:nvSpPr>
-          <p:cNvPr id="14" name="Text 12"/>
-          <p:cNvSpPr/>
-          <p:nvPr/>
-        </p:nvSpPr>
-        <p:spPr>
-          <a:xfrm>
-            <a:off x="7269480" y="1143000"/>
-            <a:ext cx="1874520" cy="914400"/>
+          <p:cNvPr id="12" name="Text 10"/>
+          <p:cNvSpPr/>
+          <p:nvPr/>
+        </p:nvSpPr>
+        <p:spPr>
+          <a:xfrm>
+            <a:off x="7360920" y="320040"/>
+            <a:ext cx="2011680" cy="1143000"/>
           </a:xfrm>
           <a:prstGeom prst="rect">
             <a:avLst/>
@@ -1310,14 +1280,14 @@
           <a:ln/>
         </p:spPr>
         <p:txBody>
-          <a:bodyPr wrap="square" lIns="762" tIns="762" rIns="762" bIns="762" rtlCol="0" anchor="ctr"/>
+          <a:bodyPr wrap="square" lIns="635" tIns="635" rIns="635" bIns="635" rtlCol="0" anchor="ctr"/>
           <a:lstStyle/>
           <a:p>
             <a:pPr algn="ctr" indent="0" marL="0">
               <a:buNone/>
             </a:pPr>
             <a:r>
-              <a:rPr lang="en-US" sz="1400" b="1" dirty="0">
+              <a:rPr lang="en-US" sz="1600" b="1" dirty="0">
                 <a:solidFill>
                   <a:srgbClr val="2F6FB5"/>
                 </a:solidFill>
@@ -1327,14 +1297,14 @@
               </a:rPr>
               <a:t>3. Training vectors</a:t>
             </a:r>
-            <a:endParaRPr lang="en-US" sz="1400" dirty="0"/>
-          </a:p>
-          <a:p>
-            <a:pPr algn="ctr" indent="0" marL="0">
-              <a:buNone/>
-            </a:pPr>
-            <a:r>
-              <a:rPr lang="en-US" sz="1100" dirty="0">
+            <a:endParaRPr lang="en-US" sz="1600" dirty="0"/>
+          </a:p>
+          <a:p>
+            <a:pPr algn="ctr" indent="0" marL="0">
+              <a:buNone/>
+            </a:pPr>
+            <a:r>
+              <a:rPr lang="en-US" sz="1300" dirty="0">
                 <a:solidFill>
                   <a:srgbClr val="1F1A33"/>
                 </a:solidFill>
@@ -1342,22 +1312,39 @@
                 <a:ea typeface="Calibri" pitchFamily="34" charset="-122"/>
                 <a:cs typeface="Calibri" pitchFamily="34" charset="-120"/>
               </a:rPr>
-              <a:t>16-D, N = 16,384</a:t>
-            </a:r>
-            <a:endParaRPr lang="en-US" sz="1400" dirty="0"/>
+              <a:t>16-D,</a:t>
+            </a:r>
+            <a:endParaRPr lang="en-US" sz="1600" dirty="0"/>
+          </a:p>
+          <a:p>
+            <a:pPr algn="ctr" indent="0" marL="0">
+              <a:buNone/>
+            </a:pPr>
+            <a:r>
+              <a:rPr lang="en-US" sz="1300" dirty="0">
+                <a:solidFill>
+                  <a:srgbClr val="1F1A33"/>
+                </a:solidFill>
+                <a:latin typeface="Calibri" pitchFamily="34" charset="0"/>
+                <a:ea typeface="Calibri" pitchFamily="34" charset="-122"/>
+                <a:cs typeface="Calibri" pitchFamily="34" charset="-120"/>
+              </a:rPr>
+              <a:t>N = 16,384</a:t>
+            </a:r>
+            <a:endParaRPr lang="en-US" sz="1600" dirty="0"/>
           </a:p>
         </p:txBody>
       </p:sp>
       <p:sp>
         <p:nvSpPr>
-          <p:cNvPr id="15" name="Text 13"/>
-          <p:cNvSpPr/>
-          <p:nvPr/>
-        </p:nvSpPr>
-        <p:spPr>
-          <a:xfrm>
-            <a:off x="6355080" y="2185416"/>
-            <a:ext cx="5029200" cy="219456"/>
+          <p:cNvPr id="13" name="Text 11"/>
+          <p:cNvSpPr/>
+          <p:nvPr/>
+        </p:nvSpPr>
+        <p:spPr>
+          <a:xfrm>
+            <a:off x="6355080" y="1591056"/>
+            <a:ext cx="5394960" cy="228600"/>
           </a:xfrm>
           <a:prstGeom prst="rect">
             <a:avLst/>
@@ -1373,7 +1360,7 @@
               <a:buNone/>
             </a:pPr>
             <a:r>
-              <a:rPr lang="en-US" sz="1100" b="1" i="1" dirty="0">
+              <a:rPr lang="en-US" sz="1300" b="1" i="1" dirty="0">
                 <a:solidFill>
                   <a:srgbClr val="E0457B"/>
                 </a:solidFill>
@@ -1383,20 +1370,20 @@
               </a:rPr>
               <a:t>16,384 training vectors (16-D)</a:t>
             </a:r>
-            <a:endParaRPr lang="en-US" sz="1100" dirty="0"/>
+            <a:endParaRPr lang="en-US" sz="1300" dirty="0"/>
           </a:p>
         </p:txBody>
       </p:sp>
       <p:sp>
         <p:nvSpPr>
-          <p:cNvPr id="16" name="Shape 14"/>
-          <p:cNvSpPr/>
-          <p:nvPr/>
-        </p:nvSpPr>
-        <p:spPr>
-          <a:xfrm>
-            <a:off x="5989320" y="2203704"/>
-            <a:ext cx="237744" cy="182880"/>
+          <p:cNvPr id="14" name="Shape 12"/>
+          <p:cNvSpPr/>
+          <p:nvPr/>
+        </p:nvSpPr>
+        <p:spPr>
+          <a:xfrm>
+            <a:off x="5989320" y="1609344"/>
+            <a:ext cx="237744" cy="192024"/>
           </a:xfrm>
           <a:prstGeom prst="downArrow">
             <a:avLst/>
@@ -1414,18 +1401,18 @@
       </p:sp>
       <p:sp>
         <p:nvSpPr>
-          <p:cNvPr id="17" name="Shape 15"/>
-          <p:cNvSpPr/>
-          <p:nvPr/>
-        </p:nvSpPr>
-        <p:spPr>
-          <a:xfrm>
-            <a:off x="411480" y="2395728"/>
-            <a:ext cx="11365992" cy="1188720"/>
+          <p:cNvPr id="15" name="Shape 13"/>
+          <p:cNvSpPr/>
+          <p:nvPr/>
+        </p:nvSpPr>
+        <p:spPr>
+          <a:xfrm>
+            <a:off x="320040" y="1810512"/>
+            <a:ext cx="11503152" cy="1417320"/>
           </a:xfrm>
           <a:prstGeom prst="roundRect">
             <a:avLst>
-              <a:gd name="adj" fmla="val 7692"/>
+              <a:gd name="adj" fmla="val 6452"/>
             </a:avLst>
           </a:prstGeom>
           <a:solidFill>
@@ -1441,18 +1428,18 @@
       </p:sp>
       <p:sp>
         <p:nvSpPr>
-          <p:cNvPr id="18" name="Shape 16"/>
-          <p:cNvSpPr/>
-          <p:nvPr/>
-        </p:nvSpPr>
-        <p:spPr>
-          <a:xfrm>
-            <a:off x="457200" y="2441448"/>
-            <a:ext cx="2148840" cy="1097280"/>
+          <p:cNvPr id="16" name="Shape 14"/>
+          <p:cNvSpPr/>
+          <p:nvPr/>
+        </p:nvSpPr>
+        <p:spPr>
+          <a:xfrm>
+            <a:off x="365760" y="1856232"/>
+            <a:ext cx="2240280" cy="1325880"/>
           </a:xfrm>
           <a:prstGeom prst="roundRect">
             <a:avLst>
-              <a:gd name="adj" fmla="val 6667"/>
+              <a:gd name="adj" fmla="val 5517"/>
             </a:avLst>
           </a:prstGeom>
           <a:solidFill>
@@ -1468,14 +1455,14 @@
       </p:sp>
       <p:sp>
         <p:nvSpPr>
-          <p:cNvPr id="19" name="Text 17"/>
-          <p:cNvSpPr/>
-          <p:nvPr/>
-        </p:nvSpPr>
-        <p:spPr>
-          <a:xfrm>
-            <a:off x="457200" y="2441448"/>
-            <a:ext cx="2148840" cy="1097280"/>
+          <p:cNvPr id="17" name="Text 15"/>
+          <p:cNvSpPr/>
+          <p:nvPr/>
+        </p:nvSpPr>
+        <p:spPr>
+          <a:xfrm>
+            <a:off x="365760" y="1856232"/>
+            <a:ext cx="2240280" cy="1325880"/>
           </a:xfrm>
           <a:prstGeom prst="rect">
             <a:avLst/>
@@ -1491,7 +1478,7 @@
               <a:buNone/>
             </a:pPr>
             <a:r>
-              <a:rPr lang="en-US" sz="1800" b="1" dirty="0">
+              <a:rPr lang="en-US" sz="2200" b="1" dirty="0">
                 <a:solidFill>
                   <a:srgbClr val="FFFFFF"/>
                 </a:solidFill>
@@ -1501,14 +1488,14 @@
               </a:rPr>
               <a:t>Stage 2</a:t>
             </a:r>
-            <a:endParaRPr lang="en-US" sz="1800" dirty="0"/>
-          </a:p>
-          <a:p>
-            <a:pPr algn="ctr" indent="0" marL="0">
-              <a:buNone/>
-            </a:pPr>
-            <a:r>
-              <a:rPr lang="en-US" sz="1300" dirty="0">
+            <a:endParaRPr lang="en-US" sz="2200" dirty="0"/>
+          </a:p>
+          <a:p>
+            <a:pPr algn="ctr" indent="0" marL="0">
+              <a:buNone/>
+            </a:pPr>
+            <a:r>
+              <a:rPr lang="en-US" sz="1500" dirty="0">
                 <a:solidFill>
                   <a:srgbClr val="FFFFFF"/>
                 </a:solidFill>
@@ -1516,26 +1503,43 @@
                 <a:ea typeface="Calibri" pitchFamily="34" charset="-122"/>
                 <a:cs typeface="Calibri" pitchFamily="34" charset="-120"/>
               </a:rPr>
-              <a:t>Parallel LBG Training (MPI)</a:t>
-            </a:r>
-            <a:endParaRPr lang="en-US" sz="1800" dirty="0"/>
+              <a:t>Parallel LBG</a:t>
+            </a:r>
+            <a:endParaRPr lang="en-US" sz="2200" dirty="0"/>
+          </a:p>
+          <a:p>
+            <a:pPr algn="ctr" indent="0" marL="0">
+              <a:buNone/>
+            </a:pPr>
+            <a:r>
+              <a:rPr lang="en-US" sz="1500" dirty="0">
+                <a:solidFill>
+                  <a:srgbClr val="FFFFFF"/>
+                </a:solidFill>
+                <a:latin typeface="Calibri" pitchFamily="34" charset="0"/>
+                <a:ea typeface="Calibri" pitchFamily="34" charset="-122"/>
+                <a:cs typeface="Calibri" pitchFamily="34" charset="-120"/>
+              </a:rPr>
+              <a:t>Training (MPI)</a:t>
+            </a:r>
+            <a:endParaRPr lang="en-US" sz="2200" dirty="0"/>
           </a:p>
         </p:txBody>
       </p:sp>
       <p:sp>
         <p:nvSpPr>
-          <p:cNvPr id="20" name="Shape 18"/>
-          <p:cNvSpPr/>
-          <p:nvPr/>
-        </p:nvSpPr>
-        <p:spPr>
-          <a:xfrm>
-            <a:off x="2788920" y="2532888"/>
-            <a:ext cx="1874520" cy="914400"/>
+          <p:cNvPr id="18" name="Shape 16"/>
+          <p:cNvSpPr/>
+          <p:nvPr/>
+        </p:nvSpPr>
+        <p:spPr>
+          <a:xfrm>
+            <a:off x="2788920" y="1947672"/>
+            <a:ext cx="2011680" cy="1143000"/>
           </a:xfrm>
           <a:prstGeom prst="roundRect">
             <a:avLst>
-              <a:gd name="adj" fmla="val 8000"/>
+              <a:gd name="adj" fmla="val 6400"/>
             </a:avLst>
           </a:prstGeom>
           <a:solidFill>
@@ -1551,14 +1555,14 @@
       </p:sp>
       <p:sp>
         <p:nvSpPr>
-          <p:cNvPr id="21" name="Text 19"/>
-          <p:cNvSpPr/>
-          <p:nvPr/>
-        </p:nvSpPr>
-        <p:spPr>
-          <a:xfrm>
-            <a:off x="2788920" y="2532888"/>
-            <a:ext cx="1874520" cy="914400"/>
+          <p:cNvPr id="19" name="Text 17"/>
+          <p:cNvSpPr/>
+          <p:nvPr/>
+        </p:nvSpPr>
+        <p:spPr>
+          <a:xfrm>
+            <a:off x="2788920" y="1947672"/>
+            <a:ext cx="2011680" cy="1143000"/>
           </a:xfrm>
           <a:prstGeom prst="rect">
             <a:avLst/>
@@ -1567,14 +1571,14 @@
           <a:ln/>
         </p:spPr>
         <p:txBody>
-          <a:bodyPr wrap="square" lIns="762" tIns="762" rIns="762" bIns="762" rtlCol="0" anchor="ctr"/>
+          <a:bodyPr wrap="square" lIns="635" tIns="635" rIns="635" bIns="635" rtlCol="0" anchor="ctr"/>
           <a:lstStyle/>
           <a:p>
             <a:pPr algn="ctr" indent="0" marL="0">
               <a:buNone/>
             </a:pPr>
             <a:r>
-              <a:rPr lang="en-US" sz="1400" b="1" dirty="0">
+              <a:rPr lang="en-US" sz="1600" b="1" dirty="0">
                 <a:solidFill>
                   <a:srgbClr val="E07B22"/>
                 </a:solidFill>
@@ -1584,14 +1588,14 @@
               </a:rPr>
               <a:t>1. Distribute</a:t>
             </a:r>
-            <a:endParaRPr lang="en-US" sz="1400" dirty="0"/>
-          </a:p>
-          <a:p>
-            <a:pPr algn="ctr" indent="0" marL="0">
-              <a:buNone/>
-            </a:pPr>
-            <a:r>
-              <a:rPr lang="en-US" sz="1100" dirty="0">
+            <a:endParaRPr lang="en-US" sz="1600" dirty="0"/>
+          </a:p>
+          <a:p>
+            <a:pPr algn="ctr" indent="0" marL="0">
+              <a:buNone/>
+            </a:pPr>
+            <a:r>
+              <a:rPr lang="en-US" sz="1300" dirty="0">
                 <a:solidFill>
                   <a:srgbClr val="1F1A33"/>
                 </a:solidFill>
@@ -1601,14 +1605,14 @@
               </a:rPr>
               <a:t>MPI_Scatterv:</a:t>
             </a:r>
-            <a:endParaRPr lang="en-US" sz="1400" dirty="0"/>
-          </a:p>
-          <a:p>
-            <a:pPr algn="ctr" indent="0" marL="0">
-              <a:buNone/>
-            </a:pPr>
-            <a:r>
-              <a:rPr lang="en-US" sz="1100" dirty="0">
+            <a:endParaRPr lang="en-US" sz="1600" dirty="0"/>
+          </a:p>
+          <a:p>
+            <a:pPr algn="ctr" indent="0" marL="0">
+              <a:buNone/>
+            </a:pPr>
+            <a:r>
+              <a:rPr lang="en-US" sz="1300" dirty="0">
                 <a:solidFill>
                   <a:srgbClr val="1F1A33"/>
                 </a:solidFill>
@@ -1618,20 +1622,20 @@
               </a:rPr>
               <a:t>Equal / Adaptive</a:t>
             </a:r>
-            <a:endParaRPr lang="en-US" sz="1400" dirty="0"/>
+            <a:endParaRPr lang="en-US" sz="1600" dirty="0"/>
           </a:p>
         </p:txBody>
       </p:sp>
       <p:sp>
         <p:nvSpPr>
-          <p:cNvPr id="22" name="Shape 20"/>
-          <p:cNvSpPr/>
-          <p:nvPr/>
-        </p:nvSpPr>
-        <p:spPr>
-          <a:xfrm>
-            <a:off x="4709160" y="2871216"/>
-            <a:ext cx="274320" cy="237744"/>
+          <p:cNvPr id="20" name="Shape 18"/>
+          <p:cNvSpPr/>
+          <p:nvPr/>
+        </p:nvSpPr>
+        <p:spPr>
+          <a:xfrm>
+            <a:off x="4828032" y="2400300"/>
+            <a:ext cx="219456" cy="237744"/>
           </a:xfrm>
           <a:prstGeom prst="rightArrow">
             <a:avLst/>
@@ -1649,18 +1653,18 @@
       </p:sp>
       <p:sp>
         <p:nvSpPr>
-          <p:cNvPr id="23" name="Shape 21"/>
-          <p:cNvSpPr/>
-          <p:nvPr/>
-        </p:nvSpPr>
-        <p:spPr>
-          <a:xfrm>
-            <a:off x="5029200" y="2532888"/>
-            <a:ext cx="1874520" cy="914400"/>
+          <p:cNvPr id="21" name="Shape 19"/>
+          <p:cNvSpPr/>
+          <p:nvPr/>
+        </p:nvSpPr>
+        <p:spPr>
+          <a:xfrm>
+            <a:off x="5074920" y="1947672"/>
+            <a:ext cx="2011680" cy="1143000"/>
           </a:xfrm>
           <a:prstGeom prst="roundRect">
             <a:avLst>
-              <a:gd name="adj" fmla="val 8000"/>
+              <a:gd name="adj" fmla="val 6400"/>
             </a:avLst>
           </a:prstGeom>
           <a:solidFill>
@@ -1676,14 +1680,14 @@
       </p:sp>
       <p:sp>
         <p:nvSpPr>
-          <p:cNvPr id="24" name="Text 22"/>
-          <p:cNvSpPr/>
-          <p:nvPr/>
-        </p:nvSpPr>
-        <p:spPr>
-          <a:xfrm>
-            <a:off x="5029200" y="2532888"/>
-            <a:ext cx="1874520" cy="914400"/>
+          <p:cNvPr id="22" name="Text 20"/>
+          <p:cNvSpPr/>
+          <p:nvPr/>
+        </p:nvSpPr>
+        <p:spPr>
+          <a:xfrm>
+            <a:off x="5074920" y="1947672"/>
+            <a:ext cx="2011680" cy="1143000"/>
           </a:xfrm>
           <a:prstGeom prst="rect">
             <a:avLst/>
@@ -1692,14 +1696,14 @@
           <a:ln/>
         </p:spPr>
         <p:txBody>
-          <a:bodyPr wrap="square" lIns="762" tIns="762" rIns="762" bIns="762" rtlCol="0" anchor="ctr"/>
+          <a:bodyPr wrap="square" lIns="635" tIns="635" rIns="635" bIns="635" rtlCol="0" anchor="ctr"/>
           <a:lstStyle/>
           <a:p>
             <a:pPr algn="ctr" indent="0" marL="0">
               <a:buNone/>
             </a:pPr>
             <a:r>
-              <a:rPr lang="en-US" sz="1400" b="1" dirty="0">
+              <a:rPr lang="en-US" sz="1600" b="1" dirty="0">
                 <a:solidFill>
                   <a:srgbClr val="E07B22"/>
                 </a:solidFill>
@@ -1709,14 +1713,14 @@
               </a:rPr>
               <a:t>2. Assign</a:t>
             </a:r>
-            <a:endParaRPr lang="en-US" sz="1400" dirty="0"/>
-          </a:p>
-          <a:p>
-            <a:pPr algn="ctr" indent="0" marL="0">
-              <a:buNone/>
-            </a:pPr>
-            <a:r>
-              <a:rPr lang="en-US" sz="1100" dirty="0">
+            <a:endParaRPr lang="en-US" sz="1600" dirty="0"/>
+          </a:p>
+          <a:p>
+            <a:pPr algn="ctr" indent="0" marL="0">
+              <a:buNone/>
+            </a:pPr>
+            <a:r>
+              <a:rPr lang="en-US" sz="1300" dirty="0">
                 <a:solidFill>
                   <a:srgbClr val="1F1A33"/>
                 </a:solidFill>
@@ -1724,22 +1728,39 @@
                 <a:ea typeface="Calibri" pitchFamily="34" charset="-122"/>
                 <a:cs typeface="Calibri" pitchFamily="34" charset="-120"/>
               </a:rPr>
-              <a:t>nearest codeword on each rank</a:t>
-            </a:r>
-            <a:endParaRPr lang="en-US" sz="1400" dirty="0"/>
+              <a:t>nearest codeword</a:t>
+            </a:r>
+            <a:endParaRPr lang="en-US" sz="1600" dirty="0"/>
+          </a:p>
+          <a:p>
+            <a:pPr algn="ctr" indent="0" marL="0">
+              <a:buNone/>
+            </a:pPr>
+            <a:r>
+              <a:rPr lang="en-US" sz="1300" dirty="0">
+                <a:solidFill>
+                  <a:srgbClr val="1F1A33"/>
+                </a:solidFill>
+                <a:latin typeface="Calibri" pitchFamily="34" charset="0"/>
+                <a:ea typeface="Calibri" pitchFamily="34" charset="-122"/>
+                <a:cs typeface="Calibri" pitchFamily="34" charset="-120"/>
+              </a:rPr>
+              <a:t>on each rank</a:t>
+            </a:r>
+            <a:endParaRPr lang="en-US" sz="1600" dirty="0"/>
           </a:p>
         </p:txBody>
       </p:sp>
       <p:sp>
         <p:nvSpPr>
-          <p:cNvPr id="25" name="Shape 23"/>
-          <p:cNvSpPr/>
-          <p:nvPr/>
-        </p:nvSpPr>
-        <p:spPr>
-          <a:xfrm>
-            <a:off x="6949440" y="2871216"/>
-            <a:ext cx="274320" cy="237744"/>
+          <p:cNvPr id="23" name="Shape 21"/>
+          <p:cNvSpPr/>
+          <p:nvPr/>
+        </p:nvSpPr>
+        <p:spPr>
+          <a:xfrm>
+            <a:off x="7114032" y="2400300"/>
+            <a:ext cx="219456" cy="237744"/>
           </a:xfrm>
           <a:prstGeom prst="rightArrow">
             <a:avLst/>
@@ -1757,18 +1778,18 @@
       </p:sp>
       <p:sp>
         <p:nvSpPr>
-          <p:cNvPr id="26" name="Shape 24"/>
-          <p:cNvSpPr/>
-          <p:nvPr/>
-        </p:nvSpPr>
-        <p:spPr>
-          <a:xfrm>
-            <a:off x="7269480" y="2532888"/>
-            <a:ext cx="1874520" cy="914400"/>
+          <p:cNvPr id="24" name="Shape 22"/>
+          <p:cNvSpPr/>
+          <p:nvPr/>
+        </p:nvSpPr>
+        <p:spPr>
+          <a:xfrm>
+            <a:off x="7360920" y="1947672"/>
+            <a:ext cx="2011680" cy="1143000"/>
           </a:xfrm>
           <a:prstGeom prst="roundRect">
             <a:avLst>
-              <a:gd name="adj" fmla="val 8000"/>
+              <a:gd name="adj" fmla="val 6400"/>
             </a:avLst>
           </a:prstGeom>
           <a:solidFill>
@@ -1784,14 +1805,14 @@
       </p:sp>
       <p:sp>
         <p:nvSpPr>
-          <p:cNvPr id="27" name="Text 25"/>
-          <p:cNvSpPr/>
-          <p:nvPr/>
-        </p:nvSpPr>
-        <p:spPr>
-          <a:xfrm>
-            <a:off x="7269480" y="2532888"/>
-            <a:ext cx="1874520" cy="914400"/>
+          <p:cNvPr id="25" name="Text 23"/>
+          <p:cNvSpPr/>
+          <p:nvPr/>
+        </p:nvSpPr>
+        <p:spPr>
+          <a:xfrm>
+            <a:off x="7360920" y="1947672"/>
+            <a:ext cx="2011680" cy="1143000"/>
           </a:xfrm>
           <a:prstGeom prst="rect">
             <a:avLst/>
@@ -1800,14 +1821,14 @@
           <a:ln/>
         </p:spPr>
         <p:txBody>
-          <a:bodyPr wrap="square" lIns="762" tIns="762" rIns="762" bIns="762" rtlCol="0" anchor="ctr"/>
+          <a:bodyPr wrap="square" lIns="635" tIns="635" rIns="635" bIns="635" rtlCol="0" anchor="ctr"/>
           <a:lstStyle/>
           <a:p>
             <a:pPr algn="ctr" indent="0" marL="0">
               <a:buNone/>
             </a:pPr>
             <a:r>
-              <a:rPr lang="en-US" sz="1400" b="1" dirty="0">
+              <a:rPr lang="en-US" sz="1600" b="1" dirty="0">
                 <a:solidFill>
                   <a:srgbClr val="E07B22"/>
                 </a:solidFill>
@@ -1817,14 +1838,14 @@
               </a:rPr>
               <a:t>3. Combine</a:t>
             </a:r>
-            <a:endParaRPr lang="en-US" sz="1400" dirty="0"/>
-          </a:p>
-          <a:p>
-            <a:pPr algn="ctr" indent="0" marL="0">
-              <a:buNone/>
-            </a:pPr>
-            <a:r>
-              <a:rPr lang="en-US" sz="1100" dirty="0">
+            <a:endParaRPr lang="en-US" sz="1600" dirty="0"/>
+          </a:p>
+          <a:p>
+            <a:pPr algn="ctr" indent="0" marL="0">
+              <a:buNone/>
+            </a:pPr>
+            <a:r>
+              <a:rPr lang="en-US" sz="1300" dirty="0">
                 <a:solidFill>
                   <a:srgbClr val="1F1A33"/>
                 </a:solidFill>
@@ -1832,16 +1853,16 @@
                 <a:ea typeface="Calibri" pitchFamily="34" charset="-122"/>
                 <a:cs typeface="Calibri" pitchFamily="34" charset="-120"/>
               </a:rPr>
-              <a:t>Allreduce:</a:t>
-            </a:r>
-            <a:endParaRPr lang="en-US" sz="1400" dirty="0"/>
-          </a:p>
-          <a:p>
-            <a:pPr algn="ctr" indent="0" marL="0">
-              <a:buNone/>
-            </a:pPr>
-            <a:r>
-              <a:rPr lang="en-US" sz="1100" dirty="0">
+              <a:t>Allreduce: sums,</a:t>
+            </a:r>
+            <a:endParaRPr lang="en-US" sz="1600" dirty="0"/>
+          </a:p>
+          <a:p>
+            <a:pPr algn="ctr" indent="0" marL="0">
+              <a:buNone/>
+            </a:pPr>
+            <a:r>
+              <a:rPr lang="en-US" sz="1300" dirty="0">
                 <a:solidFill>
                   <a:srgbClr val="1F1A33"/>
                 </a:solidFill>
@@ -1849,22 +1870,22 @@
                 <a:ea typeface="Calibri" pitchFamily="34" charset="-122"/>
                 <a:cs typeface="Calibri" pitchFamily="34" charset="-120"/>
               </a:rPr>
-              <a:t>sums, counts, distortion</a:t>
-            </a:r>
-            <a:endParaRPr lang="en-US" sz="1400" dirty="0"/>
+              <a:t>counts, distortion</a:t>
+            </a:r>
+            <a:endParaRPr lang="en-US" sz="1600" dirty="0"/>
           </a:p>
         </p:txBody>
       </p:sp>
       <p:sp>
         <p:nvSpPr>
-          <p:cNvPr id="28" name="Shape 26"/>
-          <p:cNvSpPr/>
-          <p:nvPr/>
-        </p:nvSpPr>
-        <p:spPr>
-          <a:xfrm>
-            <a:off x="9189720" y="2871216"/>
-            <a:ext cx="274320" cy="237744"/>
+          <p:cNvPr id="26" name="Shape 24"/>
+          <p:cNvSpPr/>
+          <p:nvPr/>
+        </p:nvSpPr>
+        <p:spPr>
+          <a:xfrm>
+            <a:off x="9400032" y="2400300"/>
+            <a:ext cx="219456" cy="237744"/>
           </a:xfrm>
           <a:prstGeom prst="rightArrow">
             <a:avLst/>
@@ -1882,18 +1903,18 @@
       </p:sp>
       <p:sp>
         <p:nvSpPr>
-          <p:cNvPr id="29" name="Shape 27"/>
-          <p:cNvSpPr/>
-          <p:nvPr/>
-        </p:nvSpPr>
-        <p:spPr>
-          <a:xfrm>
-            <a:off x="9509760" y="2532888"/>
-            <a:ext cx="1874520" cy="914400"/>
+          <p:cNvPr id="27" name="Shape 25"/>
+          <p:cNvSpPr/>
+          <p:nvPr/>
+        </p:nvSpPr>
+        <p:spPr>
+          <a:xfrm>
+            <a:off x="9646920" y="1947672"/>
+            <a:ext cx="2011680" cy="1143000"/>
           </a:xfrm>
           <a:prstGeom prst="roundRect">
             <a:avLst>
-              <a:gd name="adj" fmla="val 8000"/>
+              <a:gd name="adj" fmla="val 6400"/>
             </a:avLst>
           </a:prstGeom>
           <a:solidFill>
@@ -1909,14 +1930,14 @@
       </p:sp>
       <p:sp>
         <p:nvSpPr>
-          <p:cNvPr id="30" name="Text 28"/>
-          <p:cNvSpPr/>
-          <p:nvPr/>
-        </p:nvSpPr>
-        <p:spPr>
-          <a:xfrm>
-            <a:off x="9509760" y="2532888"/>
-            <a:ext cx="1874520" cy="914400"/>
+          <p:cNvPr id="28" name="Text 26"/>
+          <p:cNvSpPr/>
+          <p:nvPr/>
+        </p:nvSpPr>
+        <p:spPr>
+          <a:xfrm>
+            <a:off x="9646920" y="1947672"/>
+            <a:ext cx="2011680" cy="1143000"/>
           </a:xfrm>
           <a:prstGeom prst="rect">
             <a:avLst/>
@@ -1925,14 +1946,14 @@
           <a:ln/>
         </p:spPr>
         <p:txBody>
-          <a:bodyPr wrap="square" lIns="762" tIns="762" rIns="762" bIns="762" rtlCol="0" anchor="ctr"/>
+          <a:bodyPr wrap="square" lIns="635" tIns="635" rIns="635" bIns="635" rtlCol="0" anchor="ctr"/>
           <a:lstStyle/>
           <a:p>
             <a:pPr algn="ctr" indent="0" marL="0">
               <a:buNone/>
             </a:pPr>
             <a:r>
-              <a:rPr lang="en-US" sz="1400" b="1" dirty="0">
+              <a:rPr lang="en-US" sz="1600" b="1" dirty="0">
                 <a:solidFill>
                   <a:srgbClr val="E07B22"/>
                 </a:solidFill>
@@ -1942,14 +1963,14 @@
               </a:rPr>
               <a:t>4. Refine and split</a:t>
             </a:r>
-            <a:endParaRPr lang="en-US" sz="1400" dirty="0"/>
-          </a:p>
-          <a:p>
-            <a:pPr algn="ctr" indent="0" marL="0">
-              <a:buNone/>
-            </a:pPr>
-            <a:r>
-              <a:rPr lang="en-US" sz="1100" dirty="0">
+            <a:endParaRPr lang="en-US" sz="1600" dirty="0"/>
+          </a:p>
+          <a:p>
+            <a:pPr algn="ctr" indent="0" marL="0">
+              <a:buNone/>
+            </a:pPr>
+            <a:r>
+              <a:rPr lang="en-US" sz="1300" dirty="0">
                 <a:solidFill>
                   <a:srgbClr val="1F1A33"/>
                 </a:solidFill>
@@ -1957,22 +1978,39 @@
                 <a:ea typeface="Calibri" pitchFamily="34" charset="-122"/>
                 <a:cs typeface="Calibri" pitchFamily="34" charset="-120"/>
               </a:rPr>
-              <a:t>per level, until K = 64</a:t>
-            </a:r>
-            <a:endParaRPr lang="en-US" sz="1400" dirty="0"/>
+              <a:t>per level,</a:t>
+            </a:r>
+            <a:endParaRPr lang="en-US" sz="1600" dirty="0"/>
+          </a:p>
+          <a:p>
+            <a:pPr algn="ctr" indent="0" marL="0">
+              <a:buNone/>
+            </a:pPr>
+            <a:r>
+              <a:rPr lang="en-US" sz="1300" dirty="0">
+                <a:solidFill>
+                  <a:srgbClr val="1F1A33"/>
+                </a:solidFill>
+                <a:latin typeface="Calibri" pitchFamily="34" charset="0"/>
+                <a:ea typeface="Calibri" pitchFamily="34" charset="-122"/>
+                <a:cs typeface="Calibri" pitchFamily="34" charset="-120"/>
+              </a:rPr>
+              <a:t>until K = 64</a:t>
+            </a:r>
+            <a:endParaRPr lang="en-US" sz="1600" dirty="0"/>
           </a:p>
         </p:txBody>
       </p:sp>
       <p:sp>
         <p:nvSpPr>
-          <p:cNvPr id="31" name="Text 29"/>
-          <p:cNvSpPr/>
-          <p:nvPr/>
-        </p:nvSpPr>
-        <p:spPr>
-          <a:xfrm>
-            <a:off x="6355080" y="3575304"/>
-            <a:ext cx="5029200" cy="219456"/>
+          <p:cNvPr id="29" name="Text 27"/>
+          <p:cNvSpPr/>
+          <p:nvPr/>
+        </p:nvSpPr>
+        <p:spPr>
+          <a:xfrm>
+            <a:off x="6355080" y="3218688"/>
+            <a:ext cx="5394960" cy="228600"/>
           </a:xfrm>
           <a:prstGeom prst="rect">
             <a:avLst/>
@@ -1988,7 +2026,7 @@
               <a:buNone/>
             </a:pPr>
             <a:r>
-              <a:rPr lang="en-US" sz="1100" b="1" i="1" dirty="0">
+              <a:rPr lang="en-US" sz="1300" b="1" i="1" dirty="0">
                 <a:solidFill>
                   <a:srgbClr val="E0457B"/>
                 </a:solidFill>
@@ -1996,22 +2034,22 @@
                 <a:ea typeface="Calibri" pitchFamily="34" charset="-122"/>
                 <a:cs typeface="Calibri" pitchFamily="34" charset="-120"/>
               </a:rPr>
-              <a:t>codebook C (64 codewords) + index array L (gathered on Rank 0)</a:t>
-            </a:r>
-            <a:endParaRPr lang="en-US" sz="1100" dirty="0"/>
+              <a:t>codebook C + index array L (gathered on Rank 0)</a:t>
+            </a:r>
+            <a:endParaRPr lang="en-US" sz="1300" dirty="0"/>
           </a:p>
         </p:txBody>
       </p:sp>
       <p:sp>
         <p:nvSpPr>
-          <p:cNvPr id="32" name="Shape 30"/>
-          <p:cNvSpPr/>
-          <p:nvPr/>
-        </p:nvSpPr>
-        <p:spPr>
-          <a:xfrm>
-            <a:off x="5989320" y="3593592"/>
-            <a:ext cx="237744" cy="182880"/>
+          <p:cNvPr id="30" name="Shape 28"/>
+          <p:cNvSpPr/>
+          <p:nvPr/>
+        </p:nvSpPr>
+        <p:spPr>
+          <a:xfrm>
+            <a:off x="5989320" y="3236976"/>
+            <a:ext cx="237744" cy="192024"/>
           </a:xfrm>
           <a:prstGeom prst="downArrow">
             <a:avLst/>
@@ -2029,18 +2067,18 @@
       </p:sp>
       <p:sp>
         <p:nvSpPr>
-          <p:cNvPr id="33" name="Shape 31"/>
-          <p:cNvSpPr/>
-          <p:nvPr/>
-        </p:nvSpPr>
-        <p:spPr>
-          <a:xfrm>
-            <a:off x="411480" y="3785616"/>
-            <a:ext cx="11365992" cy="1188720"/>
+          <p:cNvPr id="31" name="Shape 29"/>
+          <p:cNvSpPr/>
+          <p:nvPr/>
+        </p:nvSpPr>
+        <p:spPr>
+          <a:xfrm>
+            <a:off x="320040" y="3438144"/>
+            <a:ext cx="11503152" cy="1417320"/>
           </a:xfrm>
           <a:prstGeom prst="roundRect">
             <a:avLst>
-              <a:gd name="adj" fmla="val 7692"/>
+              <a:gd name="adj" fmla="val 6452"/>
             </a:avLst>
           </a:prstGeom>
           <a:solidFill>
@@ -2056,18 +2094,18 @@
       </p:sp>
       <p:sp>
         <p:nvSpPr>
-          <p:cNvPr id="34" name="Shape 32"/>
-          <p:cNvSpPr/>
-          <p:nvPr/>
-        </p:nvSpPr>
-        <p:spPr>
-          <a:xfrm>
-            <a:off x="457200" y="3831336"/>
-            <a:ext cx="2148840" cy="1097280"/>
+          <p:cNvPr id="32" name="Shape 30"/>
+          <p:cNvSpPr/>
+          <p:nvPr/>
+        </p:nvSpPr>
+        <p:spPr>
+          <a:xfrm>
+            <a:off x="365760" y="3483864"/>
+            <a:ext cx="2240280" cy="1325880"/>
           </a:xfrm>
           <a:prstGeom prst="roundRect">
             <a:avLst>
-              <a:gd name="adj" fmla="val 6667"/>
+              <a:gd name="adj" fmla="val 5517"/>
             </a:avLst>
           </a:prstGeom>
           <a:solidFill>
@@ -2083,14 +2121,14 @@
       </p:sp>
       <p:sp>
         <p:nvSpPr>
-          <p:cNvPr id="35" name="Text 33"/>
-          <p:cNvSpPr/>
-          <p:nvPr/>
-        </p:nvSpPr>
-        <p:spPr>
-          <a:xfrm>
-            <a:off x="457200" y="3831336"/>
-            <a:ext cx="2148840" cy="1097280"/>
+          <p:cNvPr id="33" name="Text 31"/>
+          <p:cNvSpPr/>
+          <p:nvPr/>
+        </p:nvSpPr>
+        <p:spPr>
+          <a:xfrm>
+            <a:off x="365760" y="3483864"/>
+            <a:ext cx="2240280" cy="1325880"/>
           </a:xfrm>
           <a:prstGeom prst="rect">
             <a:avLst/>
@@ -2106,7 +2144,7 @@
               <a:buNone/>
             </a:pPr>
             <a:r>
-              <a:rPr lang="en-US" sz="1800" b="1" dirty="0">
+              <a:rPr lang="en-US" sz="2200" b="1" dirty="0">
                 <a:solidFill>
                   <a:srgbClr val="FFFFFF"/>
                 </a:solidFill>
@@ -2116,14 +2154,14 @@
               </a:rPr>
               <a:t>Stage 3</a:t>
             </a:r>
-            <a:endParaRPr lang="en-US" sz="1800" dirty="0"/>
-          </a:p>
-          <a:p>
-            <a:pPr algn="ctr" indent="0" marL="0">
-              <a:buNone/>
-            </a:pPr>
-            <a:r>
-              <a:rPr lang="en-US" sz="1300" dirty="0">
+            <a:endParaRPr lang="en-US" sz="2200" dirty="0"/>
+          </a:p>
+          <a:p>
+            <a:pPr algn="ctr" indent="0" marL="0">
+              <a:buNone/>
+            </a:pPr>
+            <a:r>
+              <a:rPr lang="en-US" sz="1500" dirty="0">
                 <a:solidFill>
                   <a:srgbClr val="FFFFFF"/>
                 </a:solidFill>
@@ -2131,26 +2169,43 @@
                 <a:ea typeface="Calibri" pitchFamily="34" charset="-122"/>
                 <a:cs typeface="Calibri" pitchFamily="34" charset="-120"/>
               </a:rPr>
-              <a:t>Lossless Index Coding (Rank 0)</a:t>
-            </a:r>
-            <a:endParaRPr lang="en-US" sz="1800" dirty="0"/>
+              <a:t>Lossless Index</a:t>
+            </a:r>
+            <a:endParaRPr lang="en-US" sz="2200" dirty="0"/>
+          </a:p>
+          <a:p>
+            <a:pPr algn="ctr" indent="0" marL="0">
+              <a:buNone/>
+            </a:pPr>
+            <a:r>
+              <a:rPr lang="en-US" sz="1500" dirty="0">
+                <a:solidFill>
+                  <a:srgbClr val="FFFFFF"/>
+                </a:solidFill>
+                <a:latin typeface="Calibri" pitchFamily="34" charset="0"/>
+                <a:ea typeface="Calibri" pitchFamily="34" charset="-122"/>
+                <a:cs typeface="Calibri" pitchFamily="34" charset="-120"/>
+              </a:rPr>
+              <a:t>Coding (Rank 0)</a:t>
+            </a:r>
+            <a:endParaRPr lang="en-US" sz="2200" dirty="0"/>
           </a:p>
         </p:txBody>
       </p:sp>
       <p:sp>
         <p:nvSpPr>
-          <p:cNvPr id="36" name="Shape 34"/>
-          <p:cNvSpPr/>
-          <p:nvPr/>
-        </p:nvSpPr>
-        <p:spPr>
-          <a:xfrm>
-            <a:off x="2788920" y="3922776"/>
-            <a:ext cx="1874520" cy="914400"/>
+          <p:cNvPr id="34" name="Shape 32"/>
+          <p:cNvSpPr/>
+          <p:nvPr/>
+        </p:nvSpPr>
+        <p:spPr>
+          <a:xfrm>
+            <a:off x="2788920" y="3575304"/>
+            <a:ext cx="2011680" cy="1143000"/>
           </a:xfrm>
           <a:prstGeom prst="roundRect">
             <a:avLst>
-              <a:gd name="adj" fmla="val 8000"/>
+              <a:gd name="adj" fmla="val 6400"/>
             </a:avLst>
           </a:prstGeom>
           <a:solidFill>
@@ -2166,14 +2221,14 @@
       </p:sp>
       <p:sp>
         <p:nvSpPr>
-          <p:cNvPr id="37" name="Text 35"/>
-          <p:cNvSpPr/>
-          <p:nvPr/>
-        </p:nvSpPr>
-        <p:spPr>
-          <a:xfrm>
-            <a:off x="2788920" y="3922776"/>
-            <a:ext cx="1874520" cy="914400"/>
+          <p:cNvPr id="35" name="Text 33"/>
+          <p:cNvSpPr/>
+          <p:nvPr/>
+        </p:nvSpPr>
+        <p:spPr>
+          <a:xfrm>
+            <a:off x="2788920" y="3575304"/>
+            <a:ext cx="2011680" cy="1143000"/>
           </a:xfrm>
           <a:prstGeom prst="rect">
             <a:avLst/>
@@ -2182,14 +2237,14 @@
           <a:ln/>
         </p:spPr>
         <p:txBody>
-          <a:bodyPr wrap="square" lIns="762" tIns="762" rIns="762" bIns="762" rtlCol="0" anchor="ctr"/>
+          <a:bodyPr wrap="square" lIns="635" tIns="635" rIns="635" bIns="635" rtlCol="0" anchor="ctr"/>
           <a:lstStyle/>
           <a:p>
             <a:pPr algn="ctr" indent="0" marL="0">
               <a:buNone/>
             </a:pPr>
             <a:r>
-              <a:rPr lang="en-US" sz="1400" b="1" dirty="0">
+              <a:rPr lang="en-US" sz="1600" b="1" dirty="0">
                 <a:solidFill>
                   <a:srgbClr val="2A9D8F"/>
                 </a:solidFill>
@@ -2199,14 +2254,14 @@
               </a:rPr>
               <a:t>1. Delta coding</a:t>
             </a:r>
-            <a:endParaRPr lang="en-US" sz="1400" dirty="0"/>
-          </a:p>
-          <a:p>
-            <a:pPr algn="ctr" indent="0" marL="0">
-              <a:buNone/>
-            </a:pPr>
-            <a:r>
-              <a:rPr lang="en-US" sz="1100" dirty="0">
+            <a:endParaRPr lang="en-US" sz="1600" dirty="0"/>
+          </a:p>
+          <a:p>
+            <a:pPr algn="ctr" indent="0" marL="0">
+              <a:buNone/>
+            </a:pPr>
+            <a:r>
+              <a:rPr lang="en-US" sz="1300" dirty="0">
                 <a:solidFill>
                   <a:srgbClr val="1F1A33"/>
                 </a:solidFill>
@@ -2214,22 +2269,39 @@
                 <a:ea typeface="Calibri" pitchFamily="34" charset="-122"/>
                 <a:cs typeface="Calibri" pitchFamily="34" charset="-120"/>
               </a:rPr>
-              <a:t>differences of VQ indices</a:t>
-            </a:r>
-            <a:endParaRPr lang="en-US" sz="1400" dirty="0"/>
+              <a:t>differences of</a:t>
+            </a:r>
+            <a:endParaRPr lang="en-US" sz="1600" dirty="0"/>
+          </a:p>
+          <a:p>
+            <a:pPr algn="ctr" indent="0" marL="0">
+              <a:buNone/>
+            </a:pPr>
+            <a:r>
+              <a:rPr lang="en-US" sz="1300" dirty="0">
+                <a:solidFill>
+                  <a:srgbClr val="1F1A33"/>
+                </a:solidFill>
+                <a:latin typeface="Calibri" pitchFamily="34" charset="0"/>
+                <a:ea typeface="Calibri" pitchFamily="34" charset="-122"/>
+                <a:cs typeface="Calibri" pitchFamily="34" charset="-120"/>
+              </a:rPr>
+              <a:t>VQ indices</a:t>
+            </a:r>
+            <a:endParaRPr lang="en-US" sz="1600" dirty="0"/>
           </a:p>
         </p:txBody>
       </p:sp>
       <p:sp>
         <p:nvSpPr>
-          <p:cNvPr id="38" name="Shape 36"/>
-          <p:cNvSpPr/>
-          <p:nvPr/>
-        </p:nvSpPr>
-        <p:spPr>
-          <a:xfrm>
-            <a:off x="4709160" y="4261104"/>
-            <a:ext cx="274320" cy="237744"/>
+          <p:cNvPr id="36" name="Shape 34"/>
+          <p:cNvSpPr/>
+          <p:nvPr/>
+        </p:nvSpPr>
+        <p:spPr>
+          <a:xfrm>
+            <a:off x="4828032" y="4027932"/>
+            <a:ext cx="219456" cy="237744"/>
           </a:xfrm>
           <a:prstGeom prst="rightArrow">
             <a:avLst/>
@@ -2247,18 +2319,18 @@
       </p:sp>
       <p:sp>
         <p:nvSpPr>
-          <p:cNvPr id="39" name="Shape 37"/>
-          <p:cNvSpPr/>
-          <p:nvPr/>
-        </p:nvSpPr>
-        <p:spPr>
-          <a:xfrm>
-            <a:off x="5029200" y="3922776"/>
-            <a:ext cx="1874520" cy="914400"/>
+          <p:cNvPr id="37" name="Shape 35"/>
+          <p:cNvSpPr/>
+          <p:nvPr/>
+        </p:nvSpPr>
+        <p:spPr>
+          <a:xfrm>
+            <a:off x="5074920" y="3575304"/>
+            <a:ext cx="2011680" cy="1143000"/>
           </a:xfrm>
           <a:prstGeom prst="roundRect">
             <a:avLst>
-              <a:gd name="adj" fmla="val 8000"/>
+              <a:gd name="adj" fmla="val 6400"/>
             </a:avLst>
           </a:prstGeom>
           <a:solidFill>
@@ -2274,14 +2346,14 @@
       </p:sp>
       <p:sp>
         <p:nvSpPr>
-          <p:cNvPr id="40" name="Text 38"/>
-          <p:cNvSpPr/>
-          <p:nvPr/>
-        </p:nvSpPr>
-        <p:spPr>
-          <a:xfrm>
-            <a:off x="5029200" y="3922776"/>
-            <a:ext cx="1874520" cy="914400"/>
+          <p:cNvPr id="38" name="Text 36"/>
+          <p:cNvSpPr/>
+          <p:nvPr/>
+        </p:nvSpPr>
+        <p:spPr>
+          <a:xfrm>
+            <a:off x="5074920" y="3575304"/>
+            <a:ext cx="2011680" cy="1143000"/>
           </a:xfrm>
           <a:prstGeom prst="rect">
             <a:avLst/>
@@ -2290,14 +2362,14 @@
           <a:ln/>
         </p:spPr>
         <p:txBody>
-          <a:bodyPr wrap="square" lIns="762" tIns="762" rIns="762" bIns="762" rtlCol="0" anchor="ctr"/>
+          <a:bodyPr wrap="square" lIns="635" tIns="635" rIns="635" bIns="635" rtlCol="0" anchor="ctr"/>
           <a:lstStyle/>
           <a:p>
             <a:pPr algn="ctr" indent="0" marL="0">
               <a:buNone/>
             </a:pPr>
             <a:r>
-              <a:rPr lang="en-US" sz="1400" b="1" dirty="0">
+              <a:rPr lang="en-US" sz="1600" b="1" dirty="0">
                 <a:solidFill>
                   <a:srgbClr val="2A9D8F"/>
                 </a:solidFill>
@@ -2307,14 +2379,14 @@
               </a:rPr>
               <a:t>2. Huffman coding</a:t>
             </a:r>
-            <a:endParaRPr lang="en-US" sz="1400" dirty="0"/>
-          </a:p>
-          <a:p>
-            <a:pPr algn="ctr" indent="0" marL="0">
-              <a:buNone/>
-            </a:pPr>
-            <a:r>
-              <a:rPr lang="en-US" sz="1100" dirty="0">
+            <a:endParaRPr lang="en-US" sz="1600" dirty="0"/>
+          </a:p>
+          <a:p>
+            <a:pPr algn="ctr" indent="0" marL="0">
+              <a:buNone/>
+            </a:pPr>
+            <a:r>
+              <a:rPr lang="en-US" sz="1300" dirty="0">
                 <a:solidFill>
                   <a:srgbClr val="1F1A33"/>
                 </a:solidFill>
@@ -2322,22 +2394,39 @@
                 <a:ea typeface="Calibri" pitchFamily="34" charset="-122"/>
                 <a:cs typeface="Calibri" pitchFamily="34" charset="-120"/>
               </a:rPr>
-              <a:t>variable-length codes</a:t>
-            </a:r>
-            <a:endParaRPr lang="en-US" sz="1400" dirty="0"/>
+              <a:t>variable-length</a:t>
+            </a:r>
+            <a:endParaRPr lang="en-US" sz="1600" dirty="0"/>
+          </a:p>
+          <a:p>
+            <a:pPr algn="ctr" indent="0" marL="0">
+              <a:buNone/>
+            </a:pPr>
+            <a:r>
+              <a:rPr lang="en-US" sz="1300" dirty="0">
+                <a:solidFill>
+                  <a:srgbClr val="1F1A33"/>
+                </a:solidFill>
+                <a:latin typeface="Calibri" pitchFamily="34" charset="0"/>
+                <a:ea typeface="Calibri" pitchFamily="34" charset="-122"/>
+                <a:cs typeface="Calibri" pitchFamily="34" charset="-120"/>
+              </a:rPr>
+              <a:t>codes</a:t>
+            </a:r>
+            <a:endParaRPr lang="en-US" sz="1600" dirty="0"/>
           </a:p>
         </p:txBody>
       </p:sp>
       <p:sp>
         <p:nvSpPr>
-          <p:cNvPr id="41" name="Shape 39"/>
-          <p:cNvSpPr/>
-          <p:nvPr/>
-        </p:nvSpPr>
-        <p:spPr>
-          <a:xfrm>
-            <a:off x="6949440" y="4261104"/>
-            <a:ext cx="274320" cy="237744"/>
+          <p:cNvPr id="39" name="Shape 37"/>
+          <p:cNvSpPr/>
+          <p:nvPr/>
+        </p:nvSpPr>
+        <p:spPr>
+          <a:xfrm>
+            <a:off x="7114032" y="4027932"/>
+            <a:ext cx="219456" cy="237744"/>
           </a:xfrm>
           <a:prstGeom prst="rightArrow">
             <a:avLst/>
@@ -2355,18 +2444,18 @@
       </p:sp>
       <p:sp>
         <p:nvSpPr>
-          <p:cNvPr id="42" name="Shape 40"/>
-          <p:cNvSpPr/>
-          <p:nvPr/>
-        </p:nvSpPr>
-        <p:spPr>
-          <a:xfrm>
-            <a:off x="7269480" y="3922776"/>
-            <a:ext cx="1874520" cy="914400"/>
+          <p:cNvPr id="40" name="Shape 38"/>
+          <p:cNvSpPr/>
+          <p:nvPr/>
+        </p:nvSpPr>
+        <p:spPr>
+          <a:xfrm>
+            <a:off x="7360920" y="3575304"/>
+            <a:ext cx="2011680" cy="1143000"/>
           </a:xfrm>
           <a:prstGeom prst="roundRect">
             <a:avLst>
-              <a:gd name="adj" fmla="val 8000"/>
+              <a:gd name="adj" fmla="val 6400"/>
             </a:avLst>
           </a:prstGeom>
           <a:solidFill>
@@ -2382,14 +2471,14 @@
       </p:sp>
       <p:sp>
         <p:nvSpPr>
-          <p:cNvPr id="43" name="Text 41"/>
-          <p:cNvSpPr/>
-          <p:nvPr/>
-        </p:nvSpPr>
-        <p:spPr>
-          <a:xfrm>
-            <a:off x="7269480" y="3922776"/>
-            <a:ext cx="1874520" cy="914400"/>
+          <p:cNvPr id="41" name="Text 39"/>
+          <p:cNvSpPr/>
+          <p:nvPr/>
+        </p:nvSpPr>
+        <p:spPr>
+          <a:xfrm>
+            <a:off x="7360920" y="3575304"/>
+            <a:ext cx="2011680" cy="1143000"/>
           </a:xfrm>
           <a:prstGeom prst="rect">
             <a:avLst/>
@@ -2398,14 +2487,14 @@
           <a:ln/>
         </p:spPr>
         <p:txBody>
-          <a:bodyPr wrap="square" lIns="762" tIns="762" rIns="762" bIns="762" rtlCol="0" anchor="ctr"/>
+          <a:bodyPr wrap="square" lIns="635" tIns="635" rIns="635" bIns="635" rtlCol="0" anchor="ctr"/>
           <a:lstStyle/>
           <a:p>
             <a:pPr algn="ctr" indent="0" marL="0">
               <a:buNone/>
             </a:pPr>
             <a:r>
-              <a:rPr lang="en-US" sz="1400" b="1" dirty="0">
+              <a:rPr lang="en-US" sz="1600" b="1" dirty="0">
                 <a:solidFill>
                   <a:srgbClr val="2A9D8F"/>
                 </a:solidFill>
@@ -2415,14 +2504,14 @@
               </a:rPr>
               <a:t>3. Compressed data</a:t>
             </a:r>
-            <a:endParaRPr lang="en-US" sz="1400" dirty="0"/>
-          </a:p>
-          <a:p>
-            <a:pPr algn="ctr" indent="0" marL="0">
-              <a:buNone/>
-            </a:pPr>
-            <a:r>
-              <a:rPr lang="en-US" sz="1100" dirty="0">
+            <a:endParaRPr lang="en-US" sz="1600" dirty="0"/>
+          </a:p>
+          <a:p>
+            <a:pPr algn="ctr" indent="0" marL="0">
+              <a:buNone/>
+            </a:pPr>
+            <a:r>
+              <a:rPr lang="en-US" sz="1300" dirty="0">
                 <a:solidFill>
                   <a:srgbClr val="1F1A33"/>
                 </a:solidFill>
@@ -2430,16 +2519,16 @@
                 <a:ea typeface="Calibri" pitchFamily="34" charset="-122"/>
                 <a:cs typeface="Calibri" pitchFamily="34" charset="-120"/>
               </a:rPr>
-              <a:t>codebook + Huffman table</a:t>
-            </a:r>
-            <a:endParaRPr lang="en-US" sz="1400" dirty="0"/>
-          </a:p>
-          <a:p>
-            <a:pPr algn="ctr" indent="0" marL="0">
-              <a:buNone/>
-            </a:pPr>
-            <a:r>
-              <a:rPr lang="en-US" sz="1100" dirty="0">
+              <a:t>codebook + Huffman</a:t>
+            </a:r>
+            <a:endParaRPr lang="en-US" sz="1600" dirty="0"/>
+          </a:p>
+          <a:p>
+            <a:pPr algn="ctr" indent="0" marL="0">
+              <a:buNone/>
+            </a:pPr>
+            <a:r>
+              <a:rPr lang="en-US" sz="1300" dirty="0">
                 <a:solidFill>
                   <a:srgbClr val="1F1A33"/>
                 </a:solidFill>
@@ -2447,22 +2536,22 @@
                 <a:ea typeface="Calibri" pitchFamily="34" charset="-122"/>
                 <a:cs typeface="Calibri" pitchFamily="34" charset="-120"/>
               </a:rPr>
-              <a:t>+ coded indices</a:t>
-            </a:r>
-            <a:endParaRPr lang="en-US" sz="1400" dirty="0"/>
+              <a:t>table + coded indices</a:t>
+            </a:r>
+            <a:endParaRPr lang="en-US" sz="1600" dirty="0"/>
           </a:p>
         </p:txBody>
       </p:sp>
       <p:sp>
         <p:nvSpPr>
-          <p:cNvPr id="44" name="Text 42"/>
-          <p:cNvSpPr/>
-          <p:nvPr/>
-        </p:nvSpPr>
-        <p:spPr>
-          <a:xfrm>
-            <a:off x="6355080" y="4965192"/>
-            <a:ext cx="5029200" cy="219456"/>
+          <p:cNvPr id="42" name="Text 40"/>
+          <p:cNvSpPr/>
+          <p:nvPr/>
+        </p:nvSpPr>
+        <p:spPr>
+          <a:xfrm>
+            <a:off x="6355080" y="4846320"/>
+            <a:ext cx="5394960" cy="228600"/>
           </a:xfrm>
           <a:prstGeom prst="rect">
             <a:avLst/>
@@ -2478,7 +2567,7 @@
               <a:buNone/>
             </a:pPr>
             <a:r>
-              <a:rPr lang="en-US" sz="1100" b="1" i="1" dirty="0">
+              <a:rPr lang="en-US" sz="1300" b="1" i="1" dirty="0">
                 <a:solidFill>
                   <a:srgbClr val="E0457B"/>
                 </a:solidFill>
@@ -2488,20 +2577,20 @@
               </a:rPr>
               <a:t>compressed data: codebook + Huffman table + coded indices</a:t>
             </a:r>
-            <a:endParaRPr lang="en-US" sz="1100" dirty="0"/>
+            <a:endParaRPr lang="en-US" sz="1300" dirty="0"/>
           </a:p>
         </p:txBody>
       </p:sp>
       <p:sp>
         <p:nvSpPr>
-          <p:cNvPr id="45" name="Shape 43"/>
-          <p:cNvSpPr/>
-          <p:nvPr/>
-        </p:nvSpPr>
-        <p:spPr>
-          <a:xfrm>
-            <a:off x="5989320" y="4983480"/>
-            <a:ext cx="237744" cy="182880"/>
+          <p:cNvPr id="43" name="Shape 41"/>
+          <p:cNvSpPr/>
+          <p:nvPr/>
+        </p:nvSpPr>
+        <p:spPr>
+          <a:xfrm>
+            <a:off x="5989320" y="4864608"/>
+            <a:ext cx="237744" cy="192024"/>
           </a:xfrm>
           <a:prstGeom prst="downArrow">
             <a:avLst/>
@@ -2519,18 +2608,18 @@
       </p:sp>
       <p:sp>
         <p:nvSpPr>
-          <p:cNvPr id="46" name="Shape 44"/>
-          <p:cNvSpPr/>
-          <p:nvPr/>
-        </p:nvSpPr>
-        <p:spPr>
-          <a:xfrm>
-            <a:off x="411480" y="5175504"/>
-            <a:ext cx="11365992" cy="1188720"/>
+          <p:cNvPr id="44" name="Shape 42"/>
+          <p:cNvSpPr/>
+          <p:nvPr/>
+        </p:nvSpPr>
+        <p:spPr>
+          <a:xfrm>
+            <a:off x="320040" y="5065776"/>
+            <a:ext cx="11503152" cy="1417320"/>
           </a:xfrm>
           <a:prstGeom prst="roundRect">
             <a:avLst>
-              <a:gd name="adj" fmla="val 7692"/>
+              <a:gd name="adj" fmla="val 6452"/>
             </a:avLst>
           </a:prstGeom>
           <a:solidFill>
@@ -2546,18 +2635,18 @@
       </p:sp>
       <p:sp>
         <p:nvSpPr>
-          <p:cNvPr id="47" name="Shape 45"/>
-          <p:cNvSpPr/>
-          <p:nvPr/>
-        </p:nvSpPr>
-        <p:spPr>
-          <a:xfrm>
-            <a:off x="457200" y="5221224"/>
-            <a:ext cx="2148840" cy="1097280"/>
+          <p:cNvPr id="45" name="Shape 43"/>
+          <p:cNvSpPr/>
+          <p:nvPr/>
+        </p:nvSpPr>
+        <p:spPr>
+          <a:xfrm>
+            <a:off x="365760" y="5111496"/>
+            <a:ext cx="2240280" cy="1325880"/>
           </a:xfrm>
           <a:prstGeom prst="roundRect">
             <a:avLst>
-              <a:gd name="adj" fmla="val 6667"/>
+              <a:gd name="adj" fmla="val 5517"/>
             </a:avLst>
           </a:prstGeom>
           <a:solidFill>
@@ -2573,14 +2662,14 @@
       </p:sp>
       <p:sp>
         <p:nvSpPr>
-          <p:cNvPr id="48" name="Text 46"/>
-          <p:cNvSpPr/>
-          <p:nvPr/>
-        </p:nvSpPr>
-        <p:spPr>
-          <a:xfrm>
-            <a:off x="457200" y="5221224"/>
-            <a:ext cx="2148840" cy="1097280"/>
+          <p:cNvPr id="46" name="Text 44"/>
+          <p:cNvSpPr/>
+          <p:nvPr/>
+        </p:nvSpPr>
+        <p:spPr>
+          <a:xfrm>
+            <a:off x="365760" y="5111496"/>
+            <a:ext cx="2240280" cy="1325880"/>
           </a:xfrm>
           <a:prstGeom prst="rect">
             <a:avLst/>
@@ -2596,7 +2685,7 @@
               <a:buNone/>
             </a:pPr>
             <a:r>
-              <a:rPr lang="en-US" sz="1800" b="1" dirty="0">
+              <a:rPr lang="en-US" sz="2200" b="1" dirty="0">
                 <a:solidFill>
                   <a:srgbClr val="FFFFFF"/>
                 </a:solidFill>
@@ -2606,14 +2695,14 @@
               </a:rPr>
               <a:t>Stage 4</a:t>
             </a:r>
-            <a:endParaRPr lang="en-US" sz="1800" dirty="0"/>
-          </a:p>
-          <a:p>
-            <a:pPr algn="ctr" indent="0" marL="0">
-              <a:buNone/>
-            </a:pPr>
-            <a:r>
-              <a:rPr lang="en-US" sz="1300" dirty="0">
+            <a:endParaRPr lang="en-US" sz="2200" dirty="0"/>
+          </a:p>
+          <a:p>
+            <a:pPr algn="ctr" indent="0" marL="0">
+              <a:buNone/>
+            </a:pPr>
+            <a:r>
+              <a:rPr lang="en-US" sz="1500" dirty="0">
                 <a:solidFill>
                   <a:srgbClr val="FFFFFF"/>
                 </a:solidFill>
@@ -2621,26 +2710,43 @@
                 <a:ea typeface="Calibri" pitchFamily="34" charset="-122"/>
                 <a:cs typeface="Calibri" pitchFamily="34" charset="-120"/>
               </a:rPr>
-              <a:t>Decoding and Evaluation</a:t>
-            </a:r>
-            <a:endParaRPr lang="en-US" sz="1800" dirty="0"/>
+              <a:t>Decoding and</a:t>
+            </a:r>
+            <a:endParaRPr lang="en-US" sz="2200" dirty="0"/>
+          </a:p>
+          <a:p>
+            <a:pPr algn="ctr" indent="0" marL="0">
+              <a:buNone/>
+            </a:pPr>
+            <a:r>
+              <a:rPr lang="en-US" sz="1500" dirty="0">
+                <a:solidFill>
+                  <a:srgbClr val="FFFFFF"/>
+                </a:solidFill>
+                <a:latin typeface="Calibri" pitchFamily="34" charset="0"/>
+                <a:ea typeface="Calibri" pitchFamily="34" charset="-122"/>
+                <a:cs typeface="Calibri" pitchFamily="34" charset="-120"/>
+              </a:rPr>
+              <a:t>Evaluation</a:t>
+            </a:r>
+            <a:endParaRPr lang="en-US" sz="2200" dirty="0"/>
           </a:p>
         </p:txBody>
       </p:sp>
       <p:sp>
         <p:nvSpPr>
-          <p:cNvPr id="49" name="Shape 47"/>
-          <p:cNvSpPr/>
-          <p:nvPr/>
-        </p:nvSpPr>
-        <p:spPr>
-          <a:xfrm>
-            <a:off x="2788920" y="5312664"/>
-            <a:ext cx="1874520" cy="914400"/>
+          <p:cNvPr id="47" name="Shape 45"/>
+          <p:cNvSpPr/>
+          <p:nvPr/>
+        </p:nvSpPr>
+        <p:spPr>
+          <a:xfrm>
+            <a:off x="2788920" y="5202936"/>
+            <a:ext cx="2011680" cy="1143000"/>
           </a:xfrm>
           <a:prstGeom prst="roundRect">
             <a:avLst>
-              <a:gd name="adj" fmla="val 8000"/>
+              <a:gd name="adj" fmla="val 6400"/>
             </a:avLst>
           </a:prstGeom>
           <a:solidFill>
@@ -2656,14 +2762,14 @@
       </p:sp>
       <p:sp>
         <p:nvSpPr>
-          <p:cNvPr id="50" name="Text 48"/>
-          <p:cNvSpPr/>
-          <p:nvPr/>
-        </p:nvSpPr>
-        <p:spPr>
-          <a:xfrm>
-            <a:off x="2788920" y="5312664"/>
-            <a:ext cx="1874520" cy="914400"/>
+          <p:cNvPr id="48" name="Text 46"/>
+          <p:cNvSpPr/>
+          <p:nvPr/>
+        </p:nvSpPr>
+        <p:spPr>
+          <a:xfrm>
+            <a:off x="2788920" y="5202936"/>
+            <a:ext cx="2011680" cy="1143000"/>
           </a:xfrm>
           <a:prstGeom prst="rect">
             <a:avLst/>
@@ -2672,14 +2778,14 @@
           <a:ln/>
         </p:spPr>
         <p:txBody>
-          <a:bodyPr wrap="square" lIns="762" tIns="762" rIns="762" bIns="762" rtlCol="0" anchor="ctr"/>
+          <a:bodyPr wrap="square" lIns="635" tIns="635" rIns="635" bIns="635" rtlCol="0" anchor="ctr"/>
           <a:lstStyle/>
           <a:p>
             <a:pPr algn="ctr" indent="0" marL="0">
               <a:buNone/>
             </a:pPr>
             <a:r>
-              <a:rPr lang="en-US" sz="1400" b="1" dirty="0">
+              <a:rPr lang="en-US" sz="1600" b="1" dirty="0">
                 <a:solidFill>
                   <a:srgbClr val="6B4FA3"/>
                 </a:solidFill>
@@ -2689,14 +2795,14 @@
               </a:rPr>
               <a:t>1. Huffman decoding</a:t>
             </a:r>
-            <a:endParaRPr lang="en-US" sz="1400" dirty="0"/>
-          </a:p>
-          <a:p>
-            <a:pPr algn="ctr" indent="0" marL="0">
-              <a:buNone/>
-            </a:pPr>
-            <a:r>
-              <a:rPr lang="en-US" sz="1100" dirty="0">
+            <a:endParaRPr lang="en-US" sz="1600" dirty="0"/>
+          </a:p>
+          <a:p>
+            <a:pPr algn="ctr" indent="0" marL="0">
+              <a:buNone/>
+            </a:pPr>
+            <a:r>
+              <a:rPr lang="en-US" sz="1300" dirty="0">
                 <a:solidFill>
                   <a:srgbClr val="1F1A33"/>
                 </a:solidFill>
@@ -2706,20 +2812,20 @@
               </a:rPr>
               <a:t>Rank 0</a:t>
             </a:r>
-            <a:endParaRPr lang="en-US" sz="1400" dirty="0"/>
+            <a:endParaRPr lang="en-US" sz="1600" dirty="0"/>
           </a:p>
         </p:txBody>
       </p:sp>
       <p:sp>
         <p:nvSpPr>
-          <p:cNvPr id="51" name="Shape 49"/>
-          <p:cNvSpPr/>
-          <p:nvPr/>
-        </p:nvSpPr>
-        <p:spPr>
-          <a:xfrm>
-            <a:off x="4709160" y="5650992"/>
-            <a:ext cx="274320" cy="237744"/>
+          <p:cNvPr id="49" name="Shape 47"/>
+          <p:cNvSpPr/>
+          <p:nvPr/>
+        </p:nvSpPr>
+        <p:spPr>
+          <a:xfrm>
+            <a:off x="4828032" y="5655564"/>
+            <a:ext cx="219456" cy="237744"/>
           </a:xfrm>
           <a:prstGeom prst="rightArrow">
             <a:avLst/>
@@ -2737,18 +2843,18 @@
       </p:sp>
       <p:sp>
         <p:nvSpPr>
-          <p:cNvPr id="52" name="Shape 50"/>
-          <p:cNvSpPr/>
-          <p:nvPr/>
-        </p:nvSpPr>
-        <p:spPr>
-          <a:xfrm>
-            <a:off x="5029200" y="5312664"/>
-            <a:ext cx="1874520" cy="914400"/>
+          <p:cNvPr id="50" name="Shape 48"/>
+          <p:cNvSpPr/>
+          <p:nvPr/>
+        </p:nvSpPr>
+        <p:spPr>
+          <a:xfrm>
+            <a:off x="5074920" y="5202936"/>
+            <a:ext cx="2011680" cy="1143000"/>
           </a:xfrm>
           <a:prstGeom prst="roundRect">
             <a:avLst>
-              <a:gd name="adj" fmla="val 8000"/>
+              <a:gd name="adj" fmla="val 6400"/>
             </a:avLst>
           </a:prstGeom>
           <a:solidFill>
@@ -2764,14 +2870,14 @@
       </p:sp>
       <p:sp>
         <p:nvSpPr>
-          <p:cNvPr id="53" name="Text 51"/>
-          <p:cNvSpPr/>
-          <p:nvPr/>
-        </p:nvSpPr>
-        <p:spPr>
-          <a:xfrm>
-            <a:off x="5029200" y="5312664"/>
-            <a:ext cx="1874520" cy="914400"/>
+          <p:cNvPr id="51" name="Text 49"/>
+          <p:cNvSpPr/>
+          <p:nvPr/>
+        </p:nvSpPr>
+        <p:spPr>
+          <a:xfrm>
+            <a:off x="5074920" y="5202936"/>
+            <a:ext cx="2011680" cy="1143000"/>
           </a:xfrm>
           <a:prstGeom prst="rect">
             <a:avLst/>
@@ -2780,14 +2886,14 @@
           <a:ln/>
         </p:spPr>
         <p:txBody>
-          <a:bodyPr wrap="square" lIns="762" tIns="762" rIns="762" bIns="762" rtlCol="0" anchor="ctr"/>
+          <a:bodyPr wrap="square" lIns="635" tIns="635" rIns="635" bIns="635" rtlCol="0" anchor="ctr"/>
           <a:lstStyle/>
           <a:p>
             <a:pPr algn="ctr" indent="0" marL="0">
               <a:buNone/>
             </a:pPr>
             <a:r>
-              <a:rPr lang="en-US" sz="1400" b="1" dirty="0">
+              <a:rPr lang="en-US" sz="1600" b="1" dirty="0">
                 <a:solidFill>
                   <a:srgbClr val="6B4FA3"/>
                 </a:solidFill>
@@ -2797,14 +2903,14 @@
               </a:rPr>
               <a:t>2. Inverse delta</a:t>
             </a:r>
-            <a:endParaRPr lang="en-US" sz="1400" dirty="0"/>
-          </a:p>
-          <a:p>
-            <a:pPr algn="ctr" indent="0" marL="0">
-              <a:buNone/>
-            </a:pPr>
-            <a:r>
-              <a:rPr lang="en-US" sz="1100" dirty="0">
+            <a:endParaRPr lang="en-US" sz="1600" dirty="0"/>
+          </a:p>
+          <a:p>
+            <a:pPr algn="ctr" indent="0" marL="0">
+              <a:buNone/>
+            </a:pPr>
+            <a:r>
+              <a:rPr lang="en-US" sz="1300" dirty="0">
                 <a:solidFill>
                   <a:srgbClr val="1F1A33"/>
                 </a:solidFill>
@@ -2812,22 +2918,39 @@
                 <a:ea typeface="Calibri" pitchFamily="34" charset="-122"/>
                 <a:cs typeface="Calibri" pitchFamily="34" charset="-120"/>
               </a:rPr>
-              <a:t>recover VQ indices</a:t>
-            </a:r>
-            <a:endParaRPr lang="en-US" sz="1400" dirty="0"/>
+              <a:t>recover</a:t>
+            </a:r>
+            <a:endParaRPr lang="en-US" sz="1600" dirty="0"/>
+          </a:p>
+          <a:p>
+            <a:pPr algn="ctr" indent="0" marL="0">
+              <a:buNone/>
+            </a:pPr>
+            <a:r>
+              <a:rPr lang="en-US" sz="1300" dirty="0">
+                <a:solidFill>
+                  <a:srgbClr val="1F1A33"/>
+                </a:solidFill>
+                <a:latin typeface="Calibri" pitchFamily="34" charset="0"/>
+                <a:ea typeface="Calibri" pitchFamily="34" charset="-122"/>
+                <a:cs typeface="Calibri" pitchFamily="34" charset="-120"/>
+              </a:rPr>
+              <a:t>VQ indices</a:t>
+            </a:r>
+            <a:endParaRPr lang="en-US" sz="1600" dirty="0"/>
           </a:p>
         </p:txBody>
       </p:sp>
       <p:sp>
         <p:nvSpPr>
-          <p:cNvPr id="54" name="Shape 52"/>
-          <p:cNvSpPr/>
-          <p:nvPr/>
-        </p:nvSpPr>
-        <p:spPr>
-          <a:xfrm>
-            <a:off x="6949440" y="5650992"/>
-            <a:ext cx="274320" cy="237744"/>
+          <p:cNvPr id="52" name="Shape 50"/>
+          <p:cNvSpPr/>
+          <p:nvPr/>
+        </p:nvSpPr>
+        <p:spPr>
+          <a:xfrm>
+            <a:off x="7114032" y="5655564"/>
+            <a:ext cx="219456" cy="237744"/>
           </a:xfrm>
           <a:prstGeom prst="rightArrow">
             <a:avLst/>
@@ -2845,18 +2968,18 @@
       </p:sp>
       <p:sp>
         <p:nvSpPr>
-          <p:cNvPr id="55" name="Shape 53"/>
-          <p:cNvSpPr/>
-          <p:nvPr/>
-        </p:nvSpPr>
-        <p:spPr>
-          <a:xfrm>
-            <a:off x="7269480" y="5312664"/>
-            <a:ext cx="1874520" cy="914400"/>
+          <p:cNvPr id="53" name="Shape 51"/>
+          <p:cNvSpPr/>
+          <p:nvPr/>
+        </p:nvSpPr>
+        <p:spPr>
+          <a:xfrm>
+            <a:off x="7360920" y="5202936"/>
+            <a:ext cx="2011680" cy="1143000"/>
           </a:xfrm>
           <a:prstGeom prst="roundRect">
             <a:avLst>
-              <a:gd name="adj" fmla="val 8000"/>
+              <a:gd name="adj" fmla="val 6400"/>
             </a:avLst>
           </a:prstGeom>
           <a:solidFill>
@@ -2872,14 +2995,14 @@
       </p:sp>
       <p:sp>
         <p:nvSpPr>
-          <p:cNvPr id="56" name="Text 54"/>
-          <p:cNvSpPr/>
-          <p:nvPr/>
-        </p:nvSpPr>
-        <p:spPr>
-          <a:xfrm>
-            <a:off x="7269480" y="5312664"/>
-            <a:ext cx="1874520" cy="914400"/>
+          <p:cNvPr id="54" name="Text 52"/>
+          <p:cNvSpPr/>
+          <p:nvPr/>
+        </p:nvSpPr>
+        <p:spPr>
+          <a:xfrm>
+            <a:off x="7360920" y="5202936"/>
+            <a:ext cx="2011680" cy="1143000"/>
           </a:xfrm>
           <a:prstGeom prst="rect">
             <a:avLst/>
@@ -2888,14 +3011,14 @@
           <a:ln/>
         </p:spPr>
         <p:txBody>
-          <a:bodyPr wrap="square" lIns="762" tIns="762" rIns="762" bIns="762" rtlCol="0" anchor="ctr"/>
+          <a:bodyPr wrap="square" lIns="635" tIns="635" rIns="635" bIns="635" rtlCol="0" anchor="ctr"/>
           <a:lstStyle/>
           <a:p>
             <a:pPr algn="ctr" indent="0" marL="0">
               <a:buNone/>
             </a:pPr>
             <a:r>
-              <a:rPr lang="en-US" sz="1400" b="1" dirty="0">
+              <a:rPr lang="en-US" sz="1600" b="1" dirty="0">
                 <a:solidFill>
                   <a:srgbClr val="6B4FA3"/>
                 </a:solidFill>
@@ -2905,14 +3028,14 @@
               </a:rPr>
               <a:t>3. Reconstruction</a:t>
             </a:r>
-            <a:endParaRPr lang="en-US" sz="1400" dirty="0"/>
-          </a:p>
-          <a:p>
-            <a:pPr algn="ctr" indent="0" marL="0">
-              <a:buNone/>
-            </a:pPr>
-            <a:r>
-              <a:rPr lang="en-US" sz="1100" dirty="0">
+            <a:endParaRPr lang="en-US" sz="1600" dirty="0"/>
+          </a:p>
+          <a:p>
+            <a:pPr algn="ctr" indent="0" marL="0">
+              <a:buNone/>
+            </a:pPr>
+            <a:r>
+              <a:rPr lang="en-US" sz="1300" dirty="0">
                 <a:solidFill>
                   <a:srgbClr val="1F1A33"/>
                 </a:solidFill>
@@ -2920,22 +3043,39 @@
                 <a:ea typeface="Calibri" pitchFamily="34" charset="-122"/>
                 <a:cs typeface="Calibri" pitchFamily="34" charset="-120"/>
               </a:rPr>
-              <a:t>codebook lookup</a:t>
-            </a:r>
-            <a:endParaRPr lang="en-US" sz="1400" dirty="0"/>
+              <a:t>codebook</a:t>
+            </a:r>
+            <a:endParaRPr lang="en-US" sz="1600" dirty="0"/>
+          </a:p>
+          <a:p>
+            <a:pPr algn="ctr" indent="0" marL="0">
+              <a:buNone/>
+            </a:pPr>
+            <a:r>
+              <a:rPr lang="en-US" sz="1300" dirty="0">
+                <a:solidFill>
+                  <a:srgbClr val="1F1A33"/>
+                </a:solidFill>
+                <a:latin typeface="Calibri" pitchFamily="34" charset="0"/>
+                <a:ea typeface="Calibri" pitchFamily="34" charset="-122"/>
+                <a:cs typeface="Calibri" pitchFamily="34" charset="-120"/>
+              </a:rPr>
+              <a:t>lookup</a:t>
+            </a:r>
+            <a:endParaRPr lang="en-US" sz="1600" dirty="0"/>
           </a:p>
         </p:txBody>
       </p:sp>
       <p:sp>
         <p:nvSpPr>
-          <p:cNvPr id="57" name="Shape 55"/>
-          <p:cNvSpPr/>
-          <p:nvPr/>
-        </p:nvSpPr>
-        <p:spPr>
-          <a:xfrm>
-            <a:off x="9189720" y="5650992"/>
-            <a:ext cx="274320" cy="237744"/>
+          <p:cNvPr id="55" name="Shape 53"/>
+          <p:cNvSpPr/>
+          <p:nvPr/>
+        </p:nvSpPr>
+        <p:spPr>
+          <a:xfrm>
+            <a:off x="9400032" y="5655564"/>
+            <a:ext cx="219456" cy="237744"/>
           </a:xfrm>
           <a:prstGeom prst="rightArrow">
             <a:avLst/>
@@ -2953,18 +3093,18 @@
       </p:sp>
       <p:sp>
         <p:nvSpPr>
-          <p:cNvPr id="58" name="Shape 56"/>
-          <p:cNvSpPr/>
-          <p:nvPr/>
-        </p:nvSpPr>
-        <p:spPr>
-          <a:xfrm>
-            <a:off x="9509760" y="5312664"/>
-            <a:ext cx="1874520" cy="914400"/>
+          <p:cNvPr id="56" name="Shape 54"/>
+          <p:cNvSpPr/>
+          <p:nvPr/>
+        </p:nvSpPr>
+        <p:spPr>
+          <a:xfrm>
+            <a:off x="9646920" y="5202936"/>
+            <a:ext cx="2011680" cy="1143000"/>
           </a:xfrm>
           <a:prstGeom prst="roundRect">
             <a:avLst>
-              <a:gd name="adj" fmla="val 8000"/>
+              <a:gd name="adj" fmla="val 6400"/>
             </a:avLst>
           </a:prstGeom>
           <a:solidFill>
@@ -2980,14 +3120,14 @@
       </p:sp>
       <p:sp>
         <p:nvSpPr>
-          <p:cNvPr id="59" name="Text 57"/>
-          <p:cNvSpPr/>
-          <p:nvPr/>
-        </p:nvSpPr>
-        <p:spPr>
-          <a:xfrm>
-            <a:off x="9509760" y="5312664"/>
-            <a:ext cx="1874520" cy="914400"/>
+          <p:cNvPr id="57" name="Text 55"/>
+          <p:cNvSpPr/>
+          <p:nvPr/>
+        </p:nvSpPr>
+        <p:spPr>
+          <a:xfrm>
+            <a:off x="9646920" y="5202936"/>
+            <a:ext cx="2011680" cy="1143000"/>
           </a:xfrm>
           <a:prstGeom prst="rect">
             <a:avLst/>
@@ -2996,14 +3136,14 @@
           <a:ln/>
         </p:spPr>
         <p:txBody>
-          <a:bodyPr wrap="square" lIns="762" tIns="762" rIns="762" bIns="762" rtlCol="0" anchor="ctr"/>
+          <a:bodyPr wrap="square" lIns="635" tIns="635" rIns="635" bIns="635" rtlCol="0" anchor="ctr"/>
           <a:lstStyle/>
           <a:p>
             <a:pPr algn="ctr" indent="0" marL="0">
               <a:buNone/>
             </a:pPr>
             <a:r>
-              <a:rPr lang="en-US" sz="1400" b="1" dirty="0">
+              <a:rPr lang="en-US" sz="1600" b="1" dirty="0">
                 <a:solidFill>
                   <a:srgbClr val="6B4FA3"/>
                 </a:solidFill>
@@ -3013,14 +3153,14 @@
               </a:rPr>
               <a:t>4. Metrics</a:t>
             </a:r>
-            <a:endParaRPr lang="en-US" sz="1400" dirty="0"/>
-          </a:p>
-          <a:p>
-            <a:pPr algn="ctr" indent="0" marL="0">
-              <a:buNone/>
-            </a:pPr>
-            <a:r>
-              <a:rPr lang="en-US" sz="1100" dirty="0">
+            <a:endParaRPr lang="en-US" sz="1600" dirty="0"/>
+          </a:p>
+          <a:p>
+            <a:pPr algn="ctr" indent="0" marL="0">
+              <a:buNone/>
+            </a:pPr>
+            <a:r>
+              <a:rPr lang="en-US" sz="1300" dirty="0">
                 <a:solidFill>
                   <a:srgbClr val="1F1A33"/>
                 </a:solidFill>
@@ -3028,16 +3168,16 @@
                 <a:ea typeface="Calibri" pitchFamily="34" charset="-122"/>
                 <a:cs typeface="Calibri" pitchFamily="34" charset="-120"/>
               </a:rPr>
-              <a:t>CR, BPP, MSE, PSNR;</a:t>
-            </a:r>
-            <a:endParaRPr lang="en-US" sz="1400" dirty="0"/>
-          </a:p>
-          <a:p>
-            <a:pPr algn="ctr" indent="0" marL="0">
-              <a:buNone/>
-            </a:pPr>
-            <a:r>
-              <a:rPr lang="en-US" sz="1100" dirty="0">
+              <a:t>CR, BPP, MSE,</a:t>
+            </a:r>
+            <a:endParaRPr lang="en-US" sz="1600" dirty="0"/>
+          </a:p>
+          <a:p>
+            <a:pPr algn="ctr" indent="0" marL="0">
+              <a:buNone/>
+            </a:pPr>
+            <a:r>
+              <a:rPr lang="en-US" sz="1300" dirty="0">
                 <a:solidFill>
                   <a:srgbClr val="1F1A33"/>
                 </a:solidFill>
@@ -3045,47 +3185,22 @@
                 <a:ea typeface="Calibri" pitchFamily="34" charset="-122"/>
                 <a:cs typeface="Calibri" pitchFamily="34" charset="-120"/>
               </a:rPr>
-              <a:t>parallel SSIM</a:t>
-            </a:r>
-            <a:endParaRPr lang="en-US" sz="1400" dirty="0"/>
+              <a:t>PSNR; parallel SSIM</a:t>
+            </a:r>
+            <a:endParaRPr lang="en-US" sz="1600" dirty="0"/>
           </a:p>
         </p:txBody>
       </p:sp>
       <p:sp>
         <p:nvSpPr>
-          <p:cNvPr id="60" name="Shape 58"/>
-          <p:cNvSpPr/>
-          <p:nvPr/>
-        </p:nvSpPr>
-        <p:spPr>
-          <a:xfrm>
-            <a:off x="5989320" y="6373368"/>
-            <a:ext cx="237744" cy="182880"/>
-          </a:xfrm>
-          <a:prstGeom prst="downArrow">
-            <a:avLst/>
-          </a:prstGeom>
-          <a:solidFill>
-            <a:srgbClr val="1F1A33"/>
-          </a:solidFill>
-          <a:ln w="12700">
-            <a:solidFill>
-              <a:srgbClr val="1F1A33"/>
-            </a:solidFill>
-            <a:prstDash val="solid"/>
-          </a:ln>
-        </p:spPr>
-      </p:sp>
-      <p:sp>
-        <p:nvSpPr>
-          <p:cNvPr id="61" name="Text 59"/>
-          <p:cNvSpPr/>
-          <p:nvPr/>
-        </p:nvSpPr>
-        <p:spPr>
-          <a:xfrm>
-            <a:off x="457200" y="6446520"/>
-            <a:ext cx="11274552" cy="274320"/>
+          <p:cNvPr id="58" name="Text 56"/>
+          <p:cNvSpPr/>
+          <p:nvPr/>
+        </p:nvSpPr>
+        <p:spPr>
+          <a:xfrm>
+            <a:off x="365760" y="6492240"/>
+            <a:ext cx="11430000" cy="274320"/>
           </a:xfrm>
           <a:prstGeom prst="rect">
             <a:avLst/>
@@ -3101,7 +3216,7 @@
               <a:buNone/>
             </a:pPr>
             <a:r>
-              <a:rPr lang="en-US" sz="1200" i="1" dirty="0">
+              <a:rPr lang="en-US" sz="1300" i="1" dirty="0">
                 <a:solidFill>
                   <a:srgbClr val="6B4FA3"/>
                 </a:solidFill>
@@ -3111,7 +3226,7 @@
               </a:rPr>
               <a:t>Parallel: LBG training and SSIM   |   Rank 0: index coding, decoding, reconstruction, and remaining metrics</a:t>
             </a:r>
-            <a:endParaRPr lang="en-US" sz="1200" dirty="0"/>
+            <a:endParaRPr lang="en-US" sz="1300" dirty="0"/>
           </a:p>
         </p:txBody>
       </p:sp>

</xml_diff>